<commit_message>
Text body options: anchorCtr, fontAlgn, overflow modes, spcFirstLastPara; RTL tables; arch warps
anchorCtr centers the text block (text boxes and table cells), fontAlgn lines up
runs by top, middle or bottom, vertOverflow ellipsis/clip drop the lines that do
not fit, horzOverflow clip cuts at the text rectangle, spcFirstLastPara keeps the
outer paragraph spacing. Right-to-left tables mirror their cells and borders.
Single-path text warps place rigid glyphs along the path by the line's alignment;
fromWordArt scales them to the path.

Co-Authored-By: Claude Opus 5.5 <noreply@anthropic.com>
</commit_message>
<xml_diff>
--- a/tests/corpus/pptx/generated/tables.pptx
+++ b/tests/corpus/pptx/generated/tables.pptx
@@ -9,6 +9,7 @@
     <p:sldId id="257" r:id="rId3"/>
     <p:sldId id="258" r:id="rId4"/>
     <p:sldId id="259" r:id="rId5"/>
+    <p:sldId id="260" r:id="rId6"/>
   </p:sldIdLst>
   <p:sldSz cx="12192000" cy="6858000"/>
   <p:notesSz cx="6858000" cy="9144000"/>
@@ -132,7 +133,7 @@
           <p:cNvPr id="2" name="Titel 1">
             <a:extLst>
               <a:ext uri="{FF2B5EF4-FFF2-40B4-BE49-F238E27FC236}">
-                <a16:creationId xmlns:a16="http://schemas.microsoft.com/office/drawing/2014/main" id="{630879BF-57E2-230D-98E0-1666B7087A6F}"/>
+                <a16:creationId xmlns:a16="http://schemas.microsoft.com/office/drawing/2014/main" id="{AD57B38F-EE50-A01F-5FD9-C494B404A18C}"/>
               </a:ext>
             </a:extLst>
           </p:cNvPr>
@@ -169,7 +170,7 @@
           <p:cNvPr id="3" name="Untertitel 2">
             <a:extLst>
               <a:ext uri="{FF2B5EF4-FFF2-40B4-BE49-F238E27FC236}">
-                <a16:creationId xmlns:a16="http://schemas.microsoft.com/office/drawing/2014/main" id="{0A468F93-7AB8-4BAB-3723-85A02315C5C2}"/>
+                <a16:creationId xmlns:a16="http://schemas.microsoft.com/office/drawing/2014/main" id="{3BFFF0FA-3794-3A29-6A41-00E7F2BEE6CB}"/>
               </a:ext>
             </a:extLst>
           </p:cNvPr>
@@ -239,7 +240,7 @@
           <p:cNvPr id="4" name="Datumsplatzhalter 3">
             <a:extLst>
               <a:ext uri="{FF2B5EF4-FFF2-40B4-BE49-F238E27FC236}">
-                <a16:creationId xmlns:a16="http://schemas.microsoft.com/office/drawing/2014/main" id="{A343919C-51D0-6839-59D1-6F4370871A02}"/>
+                <a16:creationId xmlns:a16="http://schemas.microsoft.com/office/drawing/2014/main" id="{C855792A-E9EB-CA1B-2C30-4EACB0980D1C}"/>
               </a:ext>
             </a:extLst>
           </p:cNvPr>
@@ -255,7 +256,7 @@
           <a:bodyPr/>
           <a:lstStyle/>
           <a:p>
-            <a:fld id="{2B2DA3C3-51DF-4EE9-86A1-34325403423E}" type="datetimeFigureOut">
+            <a:fld id="{278CD8EF-D6A2-48A4-B300-6579972A1288}" type="datetimeFigureOut">
               <a:rPr lang="de-DE" smtClean="0"/>
               <a:t>08.10.2026</a:t>
             </a:fld>
@@ -268,7 +269,7 @@
           <p:cNvPr id="5" name="Fußzeilenplatzhalter 4">
             <a:extLst>
               <a:ext uri="{FF2B5EF4-FFF2-40B4-BE49-F238E27FC236}">
-                <a16:creationId xmlns:a16="http://schemas.microsoft.com/office/drawing/2014/main" id="{BD37F966-BD27-A448-2D91-F830E7E3E673}"/>
+                <a16:creationId xmlns:a16="http://schemas.microsoft.com/office/drawing/2014/main" id="{E13B00AF-E091-B145-63D5-288A189D9EE5}"/>
               </a:ext>
             </a:extLst>
           </p:cNvPr>
@@ -293,7 +294,7 @@
           <p:cNvPr id="6" name="Foliennummernplatzhalter 5">
             <a:extLst>
               <a:ext uri="{FF2B5EF4-FFF2-40B4-BE49-F238E27FC236}">
-                <a16:creationId xmlns:a16="http://schemas.microsoft.com/office/drawing/2014/main" id="{9170EB45-CD1C-655B-004E-08955C98D48E}"/>
+                <a16:creationId xmlns:a16="http://schemas.microsoft.com/office/drawing/2014/main" id="{9ADA9D4E-5D1D-254C-85F7-B97720A0D50F}"/>
               </a:ext>
             </a:extLst>
           </p:cNvPr>
@@ -309,7 +310,7 @@
           <a:bodyPr/>
           <a:lstStyle/>
           <a:p>
-            <a:fld id="{4D70D18B-266E-488B-AD8F-5C6559F88AB1}" type="slidenum">
+            <a:fld id="{7C7A06F6-DCB2-44F2-9195-0F2ECB91F403}" type="slidenum">
               <a:rPr lang="de-DE" smtClean="0"/>
               <a:t>‹Nr.›</a:t>
             </a:fld>
@@ -320,7 +321,7 @@
     </p:spTree>
     <p:extLst>
       <p:ext uri="{BB962C8B-B14F-4D97-AF65-F5344CB8AC3E}">
-        <p14:creationId xmlns:p14="http://schemas.microsoft.com/office/powerpoint/2010/main" val="388042349"/>
+        <p14:creationId xmlns:p14="http://schemas.microsoft.com/office/powerpoint/2010/main" val="3153794182"/>
       </p:ext>
     </p:extLst>
   </p:cSld>
@@ -352,7 +353,7 @@
           <p:cNvPr id="2" name="Titel 1">
             <a:extLst>
               <a:ext uri="{FF2B5EF4-FFF2-40B4-BE49-F238E27FC236}">
-                <a16:creationId xmlns:a16="http://schemas.microsoft.com/office/drawing/2014/main" id="{BEF952CD-9C38-2217-0332-1AFE77777B97}"/>
+                <a16:creationId xmlns:a16="http://schemas.microsoft.com/office/drawing/2014/main" id="{972745A8-73B3-8E2C-A898-69BC80442CF8}"/>
               </a:ext>
             </a:extLst>
           </p:cNvPr>
@@ -380,7 +381,7 @@
           <p:cNvPr id="3" name="Vertikaler Textplatzhalter 2">
             <a:extLst>
               <a:ext uri="{FF2B5EF4-FFF2-40B4-BE49-F238E27FC236}">
-                <a16:creationId xmlns:a16="http://schemas.microsoft.com/office/drawing/2014/main" id="{D6AD06C6-8AD7-44D6-2EC1-D15F3AEF4E52}"/>
+                <a16:creationId xmlns:a16="http://schemas.microsoft.com/office/drawing/2014/main" id="{BE38756F-0FF3-ECBA-B397-30D15089DB08}"/>
               </a:ext>
             </a:extLst>
           </p:cNvPr>
@@ -437,7 +438,7 @@
           <p:cNvPr id="4" name="Datumsplatzhalter 3">
             <a:extLst>
               <a:ext uri="{FF2B5EF4-FFF2-40B4-BE49-F238E27FC236}">
-                <a16:creationId xmlns:a16="http://schemas.microsoft.com/office/drawing/2014/main" id="{8CDB9B44-58F1-1A7E-1EC9-C0154490B570}"/>
+                <a16:creationId xmlns:a16="http://schemas.microsoft.com/office/drawing/2014/main" id="{D6F08F76-99F4-E727-F965-F9894C8A2BC2}"/>
               </a:ext>
             </a:extLst>
           </p:cNvPr>
@@ -453,7 +454,7 @@
           <a:bodyPr/>
           <a:lstStyle/>
           <a:p>
-            <a:fld id="{2B2DA3C3-51DF-4EE9-86A1-34325403423E}" type="datetimeFigureOut">
+            <a:fld id="{278CD8EF-D6A2-48A4-B300-6579972A1288}" type="datetimeFigureOut">
               <a:rPr lang="de-DE" smtClean="0"/>
               <a:t>08.10.2026</a:t>
             </a:fld>
@@ -466,7 +467,7 @@
           <p:cNvPr id="5" name="Fußzeilenplatzhalter 4">
             <a:extLst>
               <a:ext uri="{FF2B5EF4-FFF2-40B4-BE49-F238E27FC236}">
-                <a16:creationId xmlns:a16="http://schemas.microsoft.com/office/drawing/2014/main" id="{FCA7F5FE-9B53-C0AE-EB1A-CBFEAE51175D}"/>
+                <a16:creationId xmlns:a16="http://schemas.microsoft.com/office/drawing/2014/main" id="{9D6B6C33-834A-23F7-6EFC-FF520F4CCABA}"/>
               </a:ext>
             </a:extLst>
           </p:cNvPr>
@@ -491,7 +492,7 @@
           <p:cNvPr id="6" name="Foliennummernplatzhalter 5">
             <a:extLst>
               <a:ext uri="{FF2B5EF4-FFF2-40B4-BE49-F238E27FC236}">
-                <a16:creationId xmlns:a16="http://schemas.microsoft.com/office/drawing/2014/main" id="{7605AB34-6A12-1822-CB66-A37DF90A03E0}"/>
+                <a16:creationId xmlns:a16="http://schemas.microsoft.com/office/drawing/2014/main" id="{9063ACA4-41DD-60B2-7F8A-4F461950E457}"/>
               </a:ext>
             </a:extLst>
           </p:cNvPr>
@@ -507,7 +508,7 @@
           <a:bodyPr/>
           <a:lstStyle/>
           <a:p>
-            <a:fld id="{4D70D18B-266E-488B-AD8F-5C6559F88AB1}" type="slidenum">
+            <a:fld id="{7C7A06F6-DCB2-44F2-9195-0F2ECB91F403}" type="slidenum">
               <a:rPr lang="de-DE" smtClean="0"/>
               <a:t>‹Nr.›</a:t>
             </a:fld>
@@ -518,7 +519,7 @@
     </p:spTree>
     <p:extLst>
       <p:ext uri="{BB962C8B-B14F-4D97-AF65-F5344CB8AC3E}">
-        <p14:creationId xmlns:p14="http://schemas.microsoft.com/office/powerpoint/2010/main" val="2545052734"/>
+        <p14:creationId xmlns:p14="http://schemas.microsoft.com/office/powerpoint/2010/main" val="3008045419"/>
       </p:ext>
     </p:extLst>
   </p:cSld>
@@ -550,7 +551,7 @@
           <p:cNvPr id="2" name="Vertikaler Titel 1">
             <a:extLst>
               <a:ext uri="{FF2B5EF4-FFF2-40B4-BE49-F238E27FC236}">
-                <a16:creationId xmlns:a16="http://schemas.microsoft.com/office/drawing/2014/main" id="{E654FC0E-1EE5-3349-FCB5-EFA15B7AE4BB}"/>
+                <a16:creationId xmlns:a16="http://schemas.microsoft.com/office/drawing/2014/main" id="{E0142DEE-F8FE-E7FF-F890-25DACD4095DC}"/>
               </a:ext>
             </a:extLst>
           </p:cNvPr>
@@ -583,7 +584,7 @@
           <p:cNvPr id="3" name="Vertikaler Textplatzhalter 2">
             <a:extLst>
               <a:ext uri="{FF2B5EF4-FFF2-40B4-BE49-F238E27FC236}">
-                <a16:creationId xmlns:a16="http://schemas.microsoft.com/office/drawing/2014/main" id="{BEB290E1-63A2-A6A5-BD2B-833FC4A17336}"/>
+                <a16:creationId xmlns:a16="http://schemas.microsoft.com/office/drawing/2014/main" id="{1D06FB0F-8ADB-70CC-A7F9-4C9EA342B77D}"/>
               </a:ext>
             </a:extLst>
           </p:cNvPr>
@@ -645,7 +646,7 @@
           <p:cNvPr id="4" name="Datumsplatzhalter 3">
             <a:extLst>
               <a:ext uri="{FF2B5EF4-FFF2-40B4-BE49-F238E27FC236}">
-                <a16:creationId xmlns:a16="http://schemas.microsoft.com/office/drawing/2014/main" id="{F8B91F46-F1A1-F114-EBD5-C0D2574B6647}"/>
+                <a16:creationId xmlns:a16="http://schemas.microsoft.com/office/drawing/2014/main" id="{771566EC-E815-A54E-B7A4-64AED6F3200B}"/>
               </a:ext>
             </a:extLst>
           </p:cNvPr>
@@ -661,7 +662,7 @@
           <a:bodyPr/>
           <a:lstStyle/>
           <a:p>
-            <a:fld id="{2B2DA3C3-51DF-4EE9-86A1-34325403423E}" type="datetimeFigureOut">
+            <a:fld id="{278CD8EF-D6A2-48A4-B300-6579972A1288}" type="datetimeFigureOut">
               <a:rPr lang="de-DE" smtClean="0"/>
               <a:t>08.10.2026</a:t>
             </a:fld>
@@ -674,7 +675,7 @@
           <p:cNvPr id="5" name="Fußzeilenplatzhalter 4">
             <a:extLst>
               <a:ext uri="{FF2B5EF4-FFF2-40B4-BE49-F238E27FC236}">
-                <a16:creationId xmlns:a16="http://schemas.microsoft.com/office/drawing/2014/main" id="{EC99A805-6E7B-13BF-8320-4764056D5FE7}"/>
+                <a16:creationId xmlns:a16="http://schemas.microsoft.com/office/drawing/2014/main" id="{105ACDF9-F07D-803C-077B-40486D5BE377}"/>
               </a:ext>
             </a:extLst>
           </p:cNvPr>
@@ -699,7 +700,7 @@
           <p:cNvPr id="6" name="Foliennummernplatzhalter 5">
             <a:extLst>
               <a:ext uri="{FF2B5EF4-FFF2-40B4-BE49-F238E27FC236}">
-                <a16:creationId xmlns:a16="http://schemas.microsoft.com/office/drawing/2014/main" id="{70F7580A-9372-3F85-332D-78466AF3426B}"/>
+                <a16:creationId xmlns:a16="http://schemas.microsoft.com/office/drawing/2014/main" id="{362633D2-0039-82FC-947C-C5BF7935B211}"/>
               </a:ext>
             </a:extLst>
           </p:cNvPr>
@@ -715,7 +716,7 @@
           <a:bodyPr/>
           <a:lstStyle/>
           <a:p>
-            <a:fld id="{4D70D18B-266E-488B-AD8F-5C6559F88AB1}" type="slidenum">
+            <a:fld id="{7C7A06F6-DCB2-44F2-9195-0F2ECB91F403}" type="slidenum">
               <a:rPr lang="de-DE" smtClean="0"/>
               <a:t>‹Nr.›</a:t>
             </a:fld>
@@ -726,7 +727,7 @@
     </p:spTree>
     <p:extLst>
       <p:ext uri="{BB962C8B-B14F-4D97-AF65-F5344CB8AC3E}">
-        <p14:creationId xmlns:p14="http://schemas.microsoft.com/office/powerpoint/2010/main" val="3490512368"/>
+        <p14:creationId xmlns:p14="http://schemas.microsoft.com/office/powerpoint/2010/main" val="3997766993"/>
       </p:ext>
     </p:extLst>
   </p:cSld>
@@ -758,7 +759,7 @@
           <p:cNvPr id="2" name="Titel 1">
             <a:extLst>
               <a:ext uri="{FF2B5EF4-FFF2-40B4-BE49-F238E27FC236}">
-                <a16:creationId xmlns:a16="http://schemas.microsoft.com/office/drawing/2014/main" id="{F8BD1052-8884-F508-7021-251DDD62EC92}"/>
+                <a16:creationId xmlns:a16="http://schemas.microsoft.com/office/drawing/2014/main" id="{FD088387-008A-FE99-53E0-C6419071FB79}"/>
               </a:ext>
             </a:extLst>
           </p:cNvPr>
@@ -786,7 +787,7 @@
           <p:cNvPr id="3" name="Inhaltsplatzhalter 2">
             <a:extLst>
               <a:ext uri="{FF2B5EF4-FFF2-40B4-BE49-F238E27FC236}">
-                <a16:creationId xmlns:a16="http://schemas.microsoft.com/office/drawing/2014/main" id="{E653EB8B-3CC1-58AF-A3FF-A26C294CAE29}"/>
+                <a16:creationId xmlns:a16="http://schemas.microsoft.com/office/drawing/2014/main" id="{88478148-2859-B7F3-F743-FBB955632CB9}"/>
               </a:ext>
             </a:extLst>
           </p:cNvPr>
@@ -843,7 +844,7 @@
           <p:cNvPr id="4" name="Datumsplatzhalter 3">
             <a:extLst>
               <a:ext uri="{FF2B5EF4-FFF2-40B4-BE49-F238E27FC236}">
-                <a16:creationId xmlns:a16="http://schemas.microsoft.com/office/drawing/2014/main" id="{EEE26C7A-C001-85E7-8E1A-EE829372C8D6}"/>
+                <a16:creationId xmlns:a16="http://schemas.microsoft.com/office/drawing/2014/main" id="{D4715469-1A29-36FA-60D9-00B3205DEA96}"/>
               </a:ext>
             </a:extLst>
           </p:cNvPr>
@@ -859,7 +860,7 @@
           <a:bodyPr/>
           <a:lstStyle/>
           <a:p>
-            <a:fld id="{2B2DA3C3-51DF-4EE9-86A1-34325403423E}" type="datetimeFigureOut">
+            <a:fld id="{278CD8EF-D6A2-48A4-B300-6579972A1288}" type="datetimeFigureOut">
               <a:rPr lang="de-DE" smtClean="0"/>
               <a:t>08.10.2026</a:t>
             </a:fld>
@@ -872,7 +873,7 @@
           <p:cNvPr id="5" name="Fußzeilenplatzhalter 4">
             <a:extLst>
               <a:ext uri="{FF2B5EF4-FFF2-40B4-BE49-F238E27FC236}">
-                <a16:creationId xmlns:a16="http://schemas.microsoft.com/office/drawing/2014/main" id="{5FA60683-AF1D-5E71-F05E-5C7253C65E46}"/>
+                <a16:creationId xmlns:a16="http://schemas.microsoft.com/office/drawing/2014/main" id="{A960FED4-3CED-7F6A-F7F9-D00856EBCA66}"/>
               </a:ext>
             </a:extLst>
           </p:cNvPr>
@@ -897,7 +898,7 @@
           <p:cNvPr id="6" name="Foliennummernplatzhalter 5">
             <a:extLst>
               <a:ext uri="{FF2B5EF4-FFF2-40B4-BE49-F238E27FC236}">
-                <a16:creationId xmlns:a16="http://schemas.microsoft.com/office/drawing/2014/main" id="{74A9D504-8C27-8CCC-AAC2-08130F26D083}"/>
+                <a16:creationId xmlns:a16="http://schemas.microsoft.com/office/drawing/2014/main" id="{C661DA59-CE2A-DFC9-05A1-73C042730410}"/>
               </a:ext>
             </a:extLst>
           </p:cNvPr>
@@ -913,7 +914,7 @@
           <a:bodyPr/>
           <a:lstStyle/>
           <a:p>
-            <a:fld id="{4D70D18B-266E-488B-AD8F-5C6559F88AB1}" type="slidenum">
+            <a:fld id="{7C7A06F6-DCB2-44F2-9195-0F2ECB91F403}" type="slidenum">
               <a:rPr lang="de-DE" smtClean="0"/>
               <a:t>‹Nr.›</a:t>
             </a:fld>
@@ -924,7 +925,7 @@
     </p:spTree>
     <p:extLst>
       <p:ext uri="{BB962C8B-B14F-4D97-AF65-F5344CB8AC3E}">
-        <p14:creationId xmlns:p14="http://schemas.microsoft.com/office/powerpoint/2010/main" val="1947012754"/>
+        <p14:creationId xmlns:p14="http://schemas.microsoft.com/office/powerpoint/2010/main" val="1725606267"/>
       </p:ext>
     </p:extLst>
   </p:cSld>
@@ -956,7 +957,7 @@
           <p:cNvPr id="2" name="Titel 1">
             <a:extLst>
               <a:ext uri="{FF2B5EF4-FFF2-40B4-BE49-F238E27FC236}">
-                <a16:creationId xmlns:a16="http://schemas.microsoft.com/office/drawing/2014/main" id="{9BCE9342-D737-72CB-EE6B-F2B7EA3A177E}"/>
+                <a16:creationId xmlns:a16="http://schemas.microsoft.com/office/drawing/2014/main" id="{5EBFD96F-9D04-56EE-0F3F-44FA2AA2F61E}"/>
               </a:ext>
             </a:extLst>
           </p:cNvPr>
@@ -993,7 +994,7 @@
           <p:cNvPr id="3" name="Textplatzhalter 2">
             <a:extLst>
               <a:ext uri="{FF2B5EF4-FFF2-40B4-BE49-F238E27FC236}">
-                <a16:creationId xmlns:a16="http://schemas.microsoft.com/office/drawing/2014/main" id="{79324744-FEF6-A62F-8B8D-0F50DF691972}"/>
+                <a16:creationId xmlns:a16="http://schemas.microsoft.com/office/drawing/2014/main" id="{6FF1C5DA-0741-3F9F-E54D-D70B77C845FD}"/>
               </a:ext>
             </a:extLst>
           </p:cNvPr>
@@ -1118,7 +1119,7 @@
           <p:cNvPr id="4" name="Datumsplatzhalter 3">
             <a:extLst>
               <a:ext uri="{FF2B5EF4-FFF2-40B4-BE49-F238E27FC236}">
-                <a16:creationId xmlns:a16="http://schemas.microsoft.com/office/drawing/2014/main" id="{E8305425-8CD0-561B-4611-2BA5C6C49BBD}"/>
+                <a16:creationId xmlns:a16="http://schemas.microsoft.com/office/drawing/2014/main" id="{D404EEB7-2409-2628-24BB-A339D7F89885}"/>
               </a:ext>
             </a:extLst>
           </p:cNvPr>
@@ -1134,7 +1135,7 @@
           <a:bodyPr/>
           <a:lstStyle/>
           <a:p>
-            <a:fld id="{2B2DA3C3-51DF-4EE9-86A1-34325403423E}" type="datetimeFigureOut">
+            <a:fld id="{278CD8EF-D6A2-48A4-B300-6579972A1288}" type="datetimeFigureOut">
               <a:rPr lang="de-DE" smtClean="0"/>
               <a:t>08.10.2026</a:t>
             </a:fld>
@@ -1147,7 +1148,7 @@
           <p:cNvPr id="5" name="Fußzeilenplatzhalter 4">
             <a:extLst>
               <a:ext uri="{FF2B5EF4-FFF2-40B4-BE49-F238E27FC236}">
-                <a16:creationId xmlns:a16="http://schemas.microsoft.com/office/drawing/2014/main" id="{AD0E1082-6FC1-EEE5-7CEA-4F8BDBB37C19}"/>
+                <a16:creationId xmlns:a16="http://schemas.microsoft.com/office/drawing/2014/main" id="{C24B6C75-162C-A75B-D9DB-9EDF4AD44D82}"/>
               </a:ext>
             </a:extLst>
           </p:cNvPr>
@@ -1172,7 +1173,7 @@
           <p:cNvPr id="6" name="Foliennummernplatzhalter 5">
             <a:extLst>
               <a:ext uri="{FF2B5EF4-FFF2-40B4-BE49-F238E27FC236}">
-                <a16:creationId xmlns:a16="http://schemas.microsoft.com/office/drawing/2014/main" id="{8F791316-DF5D-5DCC-0302-7DBB3A020D8D}"/>
+                <a16:creationId xmlns:a16="http://schemas.microsoft.com/office/drawing/2014/main" id="{17BC0283-4169-582C-ECD8-61A6ABBD9E3E}"/>
               </a:ext>
             </a:extLst>
           </p:cNvPr>
@@ -1188,7 +1189,7 @@
           <a:bodyPr/>
           <a:lstStyle/>
           <a:p>
-            <a:fld id="{4D70D18B-266E-488B-AD8F-5C6559F88AB1}" type="slidenum">
+            <a:fld id="{7C7A06F6-DCB2-44F2-9195-0F2ECB91F403}" type="slidenum">
               <a:rPr lang="de-DE" smtClean="0"/>
               <a:t>‹Nr.›</a:t>
             </a:fld>
@@ -1199,7 +1200,7 @@
     </p:spTree>
     <p:extLst>
       <p:ext uri="{BB962C8B-B14F-4D97-AF65-F5344CB8AC3E}">
-        <p14:creationId xmlns:p14="http://schemas.microsoft.com/office/powerpoint/2010/main" val="125718561"/>
+        <p14:creationId xmlns:p14="http://schemas.microsoft.com/office/powerpoint/2010/main" val="1602042546"/>
       </p:ext>
     </p:extLst>
   </p:cSld>
@@ -1231,7 +1232,7 @@
           <p:cNvPr id="2" name="Titel 1">
             <a:extLst>
               <a:ext uri="{FF2B5EF4-FFF2-40B4-BE49-F238E27FC236}">
-                <a16:creationId xmlns:a16="http://schemas.microsoft.com/office/drawing/2014/main" id="{A2D71B35-AF73-620E-FDB4-EC33C6DA5A17}"/>
+                <a16:creationId xmlns:a16="http://schemas.microsoft.com/office/drawing/2014/main" id="{A33C72B5-9BD0-834B-C53B-8AD3E4386BFB}"/>
               </a:ext>
             </a:extLst>
           </p:cNvPr>
@@ -1259,7 +1260,7 @@
           <p:cNvPr id="3" name="Inhaltsplatzhalter 2">
             <a:extLst>
               <a:ext uri="{FF2B5EF4-FFF2-40B4-BE49-F238E27FC236}">
-                <a16:creationId xmlns:a16="http://schemas.microsoft.com/office/drawing/2014/main" id="{D01E395F-27C7-7D24-F87D-37ABFFB68B45}"/>
+                <a16:creationId xmlns:a16="http://schemas.microsoft.com/office/drawing/2014/main" id="{DC60DF1D-930F-2AE2-D407-88513979BA12}"/>
               </a:ext>
             </a:extLst>
           </p:cNvPr>
@@ -1321,7 +1322,7 @@
           <p:cNvPr id="4" name="Inhaltsplatzhalter 3">
             <a:extLst>
               <a:ext uri="{FF2B5EF4-FFF2-40B4-BE49-F238E27FC236}">
-                <a16:creationId xmlns:a16="http://schemas.microsoft.com/office/drawing/2014/main" id="{F72DFCDF-F5E4-4ADC-7664-9BB3ED9009FE}"/>
+                <a16:creationId xmlns:a16="http://schemas.microsoft.com/office/drawing/2014/main" id="{09223ECD-E3D1-50E0-67CE-EE2E6386FF78}"/>
               </a:ext>
             </a:extLst>
           </p:cNvPr>
@@ -1383,7 +1384,7 @@
           <p:cNvPr id="5" name="Datumsplatzhalter 4">
             <a:extLst>
               <a:ext uri="{FF2B5EF4-FFF2-40B4-BE49-F238E27FC236}">
-                <a16:creationId xmlns:a16="http://schemas.microsoft.com/office/drawing/2014/main" id="{CA50B8CA-3220-18FA-0679-A60CC777D847}"/>
+                <a16:creationId xmlns:a16="http://schemas.microsoft.com/office/drawing/2014/main" id="{78CBDAD4-E765-8E95-A1B8-44A04D4F2C54}"/>
               </a:ext>
             </a:extLst>
           </p:cNvPr>
@@ -1399,7 +1400,7 @@
           <a:bodyPr/>
           <a:lstStyle/>
           <a:p>
-            <a:fld id="{2B2DA3C3-51DF-4EE9-86A1-34325403423E}" type="datetimeFigureOut">
+            <a:fld id="{278CD8EF-D6A2-48A4-B300-6579972A1288}" type="datetimeFigureOut">
               <a:rPr lang="de-DE" smtClean="0"/>
               <a:t>08.10.2026</a:t>
             </a:fld>
@@ -1412,7 +1413,7 @@
           <p:cNvPr id="6" name="Fußzeilenplatzhalter 5">
             <a:extLst>
               <a:ext uri="{FF2B5EF4-FFF2-40B4-BE49-F238E27FC236}">
-                <a16:creationId xmlns:a16="http://schemas.microsoft.com/office/drawing/2014/main" id="{68B1C70A-0527-C60B-2EDF-1A6F0D73F977}"/>
+                <a16:creationId xmlns:a16="http://schemas.microsoft.com/office/drawing/2014/main" id="{CD66A80C-78DD-C828-EF66-AFDE96DC7818}"/>
               </a:ext>
             </a:extLst>
           </p:cNvPr>
@@ -1437,7 +1438,7 @@
           <p:cNvPr id="7" name="Foliennummernplatzhalter 6">
             <a:extLst>
               <a:ext uri="{FF2B5EF4-FFF2-40B4-BE49-F238E27FC236}">
-                <a16:creationId xmlns:a16="http://schemas.microsoft.com/office/drawing/2014/main" id="{4FFF8C01-D8AE-7C1D-7648-56EC49BFC5B8}"/>
+                <a16:creationId xmlns:a16="http://schemas.microsoft.com/office/drawing/2014/main" id="{D29C464E-CE0D-33F7-82DD-605CA1870A1C}"/>
               </a:ext>
             </a:extLst>
           </p:cNvPr>
@@ -1453,7 +1454,7 @@
           <a:bodyPr/>
           <a:lstStyle/>
           <a:p>
-            <a:fld id="{4D70D18B-266E-488B-AD8F-5C6559F88AB1}" type="slidenum">
+            <a:fld id="{7C7A06F6-DCB2-44F2-9195-0F2ECB91F403}" type="slidenum">
               <a:rPr lang="de-DE" smtClean="0"/>
               <a:t>‹Nr.›</a:t>
             </a:fld>
@@ -1464,7 +1465,7 @@
     </p:spTree>
     <p:extLst>
       <p:ext uri="{BB962C8B-B14F-4D97-AF65-F5344CB8AC3E}">
-        <p14:creationId xmlns:p14="http://schemas.microsoft.com/office/powerpoint/2010/main" val="3625023054"/>
+        <p14:creationId xmlns:p14="http://schemas.microsoft.com/office/powerpoint/2010/main" val="1497341423"/>
       </p:ext>
     </p:extLst>
   </p:cSld>
@@ -1496,7 +1497,7 @@
           <p:cNvPr id="2" name="Titel 1">
             <a:extLst>
               <a:ext uri="{FF2B5EF4-FFF2-40B4-BE49-F238E27FC236}">
-                <a16:creationId xmlns:a16="http://schemas.microsoft.com/office/drawing/2014/main" id="{BCFC7A44-7463-7D04-38EA-4991745ED166}"/>
+                <a16:creationId xmlns:a16="http://schemas.microsoft.com/office/drawing/2014/main" id="{4BC53A37-6671-D984-E45E-47616FD95530}"/>
               </a:ext>
             </a:extLst>
           </p:cNvPr>
@@ -1529,7 +1530,7 @@
           <p:cNvPr id="3" name="Textplatzhalter 2">
             <a:extLst>
               <a:ext uri="{FF2B5EF4-FFF2-40B4-BE49-F238E27FC236}">
-                <a16:creationId xmlns:a16="http://schemas.microsoft.com/office/drawing/2014/main" id="{59A47775-B16F-1F80-DA18-05AB1FA2F274}"/>
+                <a16:creationId xmlns:a16="http://schemas.microsoft.com/office/drawing/2014/main" id="{51510203-FE24-5DDB-F9C6-23B49D0662CC}"/>
               </a:ext>
             </a:extLst>
           </p:cNvPr>
@@ -1600,7 +1601,7 @@
           <p:cNvPr id="4" name="Inhaltsplatzhalter 3">
             <a:extLst>
               <a:ext uri="{FF2B5EF4-FFF2-40B4-BE49-F238E27FC236}">
-                <a16:creationId xmlns:a16="http://schemas.microsoft.com/office/drawing/2014/main" id="{630E3EDF-8097-4235-8976-E9426AF76102}"/>
+                <a16:creationId xmlns:a16="http://schemas.microsoft.com/office/drawing/2014/main" id="{8E4D5F1B-9563-2129-6E93-71D1FB388DE7}"/>
               </a:ext>
             </a:extLst>
           </p:cNvPr>
@@ -1662,7 +1663,7 @@
           <p:cNvPr id="5" name="Textplatzhalter 4">
             <a:extLst>
               <a:ext uri="{FF2B5EF4-FFF2-40B4-BE49-F238E27FC236}">
-                <a16:creationId xmlns:a16="http://schemas.microsoft.com/office/drawing/2014/main" id="{3D70609E-760D-6DE4-1DDE-6D00359C734C}"/>
+                <a16:creationId xmlns:a16="http://schemas.microsoft.com/office/drawing/2014/main" id="{19E943C2-ADC5-4FBA-1B19-B3BE63655358}"/>
               </a:ext>
             </a:extLst>
           </p:cNvPr>
@@ -1733,7 +1734,7 @@
           <p:cNvPr id="6" name="Inhaltsplatzhalter 5">
             <a:extLst>
               <a:ext uri="{FF2B5EF4-FFF2-40B4-BE49-F238E27FC236}">
-                <a16:creationId xmlns:a16="http://schemas.microsoft.com/office/drawing/2014/main" id="{32929E0A-2A7A-9A8F-76C3-222ED5319745}"/>
+                <a16:creationId xmlns:a16="http://schemas.microsoft.com/office/drawing/2014/main" id="{84E0AE93-1407-5907-FD84-A6A4FF0D56D2}"/>
               </a:ext>
             </a:extLst>
           </p:cNvPr>
@@ -1795,7 +1796,7 @@
           <p:cNvPr id="7" name="Datumsplatzhalter 6">
             <a:extLst>
               <a:ext uri="{FF2B5EF4-FFF2-40B4-BE49-F238E27FC236}">
-                <a16:creationId xmlns:a16="http://schemas.microsoft.com/office/drawing/2014/main" id="{DBE464F7-0DAE-03E2-F83A-95E7B19DF47C}"/>
+                <a16:creationId xmlns:a16="http://schemas.microsoft.com/office/drawing/2014/main" id="{CA858D30-E1B3-2B5C-3772-28351B4CE1FD}"/>
               </a:ext>
             </a:extLst>
           </p:cNvPr>
@@ -1811,7 +1812,7 @@
           <a:bodyPr/>
           <a:lstStyle/>
           <a:p>
-            <a:fld id="{2B2DA3C3-51DF-4EE9-86A1-34325403423E}" type="datetimeFigureOut">
+            <a:fld id="{278CD8EF-D6A2-48A4-B300-6579972A1288}" type="datetimeFigureOut">
               <a:rPr lang="de-DE" smtClean="0"/>
               <a:t>08.10.2026</a:t>
             </a:fld>
@@ -1824,7 +1825,7 @@
           <p:cNvPr id="8" name="Fußzeilenplatzhalter 7">
             <a:extLst>
               <a:ext uri="{FF2B5EF4-FFF2-40B4-BE49-F238E27FC236}">
-                <a16:creationId xmlns:a16="http://schemas.microsoft.com/office/drawing/2014/main" id="{784A6B35-FE68-03C3-544B-D3BA2D318430}"/>
+                <a16:creationId xmlns:a16="http://schemas.microsoft.com/office/drawing/2014/main" id="{30847A26-CCCE-C684-FD76-479D63FB77AF}"/>
               </a:ext>
             </a:extLst>
           </p:cNvPr>
@@ -1849,7 +1850,7 @@
           <p:cNvPr id="9" name="Foliennummernplatzhalter 8">
             <a:extLst>
               <a:ext uri="{FF2B5EF4-FFF2-40B4-BE49-F238E27FC236}">
-                <a16:creationId xmlns:a16="http://schemas.microsoft.com/office/drawing/2014/main" id="{363DD9FB-10D4-833B-558A-E74341DB7D7D}"/>
+                <a16:creationId xmlns:a16="http://schemas.microsoft.com/office/drawing/2014/main" id="{FA1401A9-2364-00D0-3AE9-D4CB99A11190}"/>
               </a:ext>
             </a:extLst>
           </p:cNvPr>
@@ -1865,7 +1866,7 @@
           <a:bodyPr/>
           <a:lstStyle/>
           <a:p>
-            <a:fld id="{4D70D18B-266E-488B-AD8F-5C6559F88AB1}" type="slidenum">
+            <a:fld id="{7C7A06F6-DCB2-44F2-9195-0F2ECB91F403}" type="slidenum">
               <a:rPr lang="de-DE" smtClean="0"/>
               <a:t>‹Nr.›</a:t>
             </a:fld>
@@ -1876,7 +1877,7 @@
     </p:spTree>
     <p:extLst>
       <p:ext uri="{BB962C8B-B14F-4D97-AF65-F5344CB8AC3E}">
-        <p14:creationId xmlns:p14="http://schemas.microsoft.com/office/powerpoint/2010/main" val="3900055088"/>
+        <p14:creationId xmlns:p14="http://schemas.microsoft.com/office/powerpoint/2010/main" val="167169403"/>
       </p:ext>
     </p:extLst>
   </p:cSld>
@@ -1908,7 +1909,7 @@
           <p:cNvPr id="2" name="Titel 1">
             <a:extLst>
               <a:ext uri="{FF2B5EF4-FFF2-40B4-BE49-F238E27FC236}">
-                <a16:creationId xmlns:a16="http://schemas.microsoft.com/office/drawing/2014/main" id="{16391ECD-1F06-C58E-62C8-4E32C907D140}"/>
+                <a16:creationId xmlns:a16="http://schemas.microsoft.com/office/drawing/2014/main" id="{2E50D726-3112-DBD9-496A-21977676403B}"/>
               </a:ext>
             </a:extLst>
           </p:cNvPr>
@@ -1936,7 +1937,7 @@
           <p:cNvPr id="3" name="Datumsplatzhalter 2">
             <a:extLst>
               <a:ext uri="{FF2B5EF4-FFF2-40B4-BE49-F238E27FC236}">
-                <a16:creationId xmlns:a16="http://schemas.microsoft.com/office/drawing/2014/main" id="{A06FD152-4900-184D-CE81-90DECCED6D6F}"/>
+                <a16:creationId xmlns:a16="http://schemas.microsoft.com/office/drawing/2014/main" id="{0FA3AEF2-F702-803A-3116-C57804857661}"/>
               </a:ext>
             </a:extLst>
           </p:cNvPr>
@@ -1952,7 +1953,7 @@
           <a:bodyPr/>
           <a:lstStyle/>
           <a:p>
-            <a:fld id="{2B2DA3C3-51DF-4EE9-86A1-34325403423E}" type="datetimeFigureOut">
+            <a:fld id="{278CD8EF-D6A2-48A4-B300-6579972A1288}" type="datetimeFigureOut">
               <a:rPr lang="de-DE" smtClean="0"/>
               <a:t>08.10.2026</a:t>
             </a:fld>
@@ -1965,7 +1966,7 @@
           <p:cNvPr id="4" name="Fußzeilenplatzhalter 3">
             <a:extLst>
               <a:ext uri="{FF2B5EF4-FFF2-40B4-BE49-F238E27FC236}">
-                <a16:creationId xmlns:a16="http://schemas.microsoft.com/office/drawing/2014/main" id="{8A56565F-B7D8-D8C1-A08F-349724CDCF56}"/>
+                <a16:creationId xmlns:a16="http://schemas.microsoft.com/office/drawing/2014/main" id="{58F70AFA-B58F-6FFD-007B-BD4D4EBB3794}"/>
               </a:ext>
             </a:extLst>
           </p:cNvPr>
@@ -1990,7 +1991,7 @@
           <p:cNvPr id="5" name="Foliennummernplatzhalter 4">
             <a:extLst>
               <a:ext uri="{FF2B5EF4-FFF2-40B4-BE49-F238E27FC236}">
-                <a16:creationId xmlns:a16="http://schemas.microsoft.com/office/drawing/2014/main" id="{6C6B75A4-31EA-880B-1EDF-AEAD9C2AC434}"/>
+                <a16:creationId xmlns:a16="http://schemas.microsoft.com/office/drawing/2014/main" id="{0E1326AF-D988-0586-1BCD-A2CB51434137}"/>
               </a:ext>
             </a:extLst>
           </p:cNvPr>
@@ -2006,7 +2007,7 @@
           <a:bodyPr/>
           <a:lstStyle/>
           <a:p>
-            <a:fld id="{4D70D18B-266E-488B-AD8F-5C6559F88AB1}" type="slidenum">
+            <a:fld id="{7C7A06F6-DCB2-44F2-9195-0F2ECB91F403}" type="slidenum">
               <a:rPr lang="de-DE" smtClean="0"/>
               <a:t>‹Nr.›</a:t>
             </a:fld>
@@ -2017,7 +2018,7 @@
     </p:spTree>
     <p:extLst>
       <p:ext uri="{BB962C8B-B14F-4D97-AF65-F5344CB8AC3E}">
-        <p14:creationId xmlns:p14="http://schemas.microsoft.com/office/powerpoint/2010/main" val="2048302020"/>
+        <p14:creationId xmlns:p14="http://schemas.microsoft.com/office/powerpoint/2010/main" val="1268123194"/>
       </p:ext>
     </p:extLst>
   </p:cSld>
@@ -2049,7 +2050,7 @@
           <p:cNvPr id="2" name="Datumsplatzhalter 1">
             <a:extLst>
               <a:ext uri="{FF2B5EF4-FFF2-40B4-BE49-F238E27FC236}">
-                <a16:creationId xmlns:a16="http://schemas.microsoft.com/office/drawing/2014/main" id="{221778E6-2DBF-6471-29A2-F5624DF8C1FE}"/>
+                <a16:creationId xmlns:a16="http://schemas.microsoft.com/office/drawing/2014/main" id="{4BF0B750-5608-972F-D261-EB7E70BA405E}"/>
               </a:ext>
             </a:extLst>
           </p:cNvPr>
@@ -2065,7 +2066,7 @@
           <a:bodyPr/>
           <a:lstStyle/>
           <a:p>
-            <a:fld id="{2B2DA3C3-51DF-4EE9-86A1-34325403423E}" type="datetimeFigureOut">
+            <a:fld id="{278CD8EF-D6A2-48A4-B300-6579972A1288}" type="datetimeFigureOut">
               <a:rPr lang="de-DE" smtClean="0"/>
               <a:t>08.10.2026</a:t>
             </a:fld>
@@ -2078,7 +2079,7 @@
           <p:cNvPr id="3" name="Fußzeilenplatzhalter 2">
             <a:extLst>
               <a:ext uri="{FF2B5EF4-FFF2-40B4-BE49-F238E27FC236}">
-                <a16:creationId xmlns:a16="http://schemas.microsoft.com/office/drawing/2014/main" id="{63D7FE91-5630-2249-6A8C-C7EF305A551A}"/>
+                <a16:creationId xmlns:a16="http://schemas.microsoft.com/office/drawing/2014/main" id="{507882F3-BB38-B51E-F688-60EB663BCE7D}"/>
               </a:ext>
             </a:extLst>
           </p:cNvPr>
@@ -2103,7 +2104,7 @@
           <p:cNvPr id="4" name="Foliennummernplatzhalter 3">
             <a:extLst>
               <a:ext uri="{FF2B5EF4-FFF2-40B4-BE49-F238E27FC236}">
-                <a16:creationId xmlns:a16="http://schemas.microsoft.com/office/drawing/2014/main" id="{736F8B07-6D89-B248-3DE4-7D83D58075A1}"/>
+                <a16:creationId xmlns:a16="http://schemas.microsoft.com/office/drawing/2014/main" id="{47A80769-8CBF-FDC3-6140-51F6979A5A98}"/>
               </a:ext>
             </a:extLst>
           </p:cNvPr>
@@ -2119,7 +2120,7 @@
           <a:bodyPr/>
           <a:lstStyle/>
           <a:p>
-            <a:fld id="{4D70D18B-266E-488B-AD8F-5C6559F88AB1}" type="slidenum">
+            <a:fld id="{7C7A06F6-DCB2-44F2-9195-0F2ECB91F403}" type="slidenum">
               <a:rPr lang="de-DE" smtClean="0"/>
               <a:t>‹Nr.›</a:t>
             </a:fld>
@@ -2130,7 +2131,7 @@
     </p:spTree>
     <p:extLst>
       <p:ext uri="{BB962C8B-B14F-4D97-AF65-F5344CB8AC3E}">
-        <p14:creationId xmlns:p14="http://schemas.microsoft.com/office/powerpoint/2010/main" val="3690541066"/>
+        <p14:creationId xmlns:p14="http://schemas.microsoft.com/office/powerpoint/2010/main" val="3782219358"/>
       </p:ext>
     </p:extLst>
   </p:cSld>
@@ -2162,7 +2163,7 @@
           <p:cNvPr id="2" name="Titel 1">
             <a:extLst>
               <a:ext uri="{FF2B5EF4-FFF2-40B4-BE49-F238E27FC236}">
-                <a16:creationId xmlns:a16="http://schemas.microsoft.com/office/drawing/2014/main" id="{697D8B9E-B29D-67E9-2579-34643B1173D8}"/>
+                <a16:creationId xmlns:a16="http://schemas.microsoft.com/office/drawing/2014/main" id="{7B4F1314-4023-5CD5-1614-B7C91309A0CD}"/>
               </a:ext>
             </a:extLst>
           </p:cNvPr>
@@ -2199,7 +2200,7 @@
           <p:cNvPr id="3" name="Inhaltsplatzhalter 2">
             <a:extLst>
               <a:ext uri="{FF2B5EF4-FFF2-40B4-BE49-F238E27FC236}">
-                <a16:creationId xmlns:a16="http://schemas.microsoft.com/office/drawing/2014/main" id="{EFFFD136-9624-4B23-ECF0-051D5E4E1BC0}"/>
+                <a16:creationId xmlns:a16="http://schemas.microsoft.com/office/drawing/2014/main" id="{D000E1A9-D836-9C8A-2DDA-82BC193885E3}"/>
               </a:ext>
             </a:extLst>
           </p:cNvPr>
@@ -2289,7 +2290,7 @@
           <p:cNvPr id="4" name="Textplatzhalter 3">
             <a:extLst>
               <a:ext uri="{FF2B5EF4-FFF2-40B4-BE49-F238E27FC236}">
-                <a16:creationId xmlns:a16="http://schemas.microsoft.com/office/drawing/2014/main" id="{42C62741-FB90-2EB9-2EBB-E7375C90E66A}"/>
+                <a16:creationId xmlns:a16="http://schemas.microsoft.com/office/drawing/2014/main" id="{22359544-2D0D-1097-8B5F-94071C2FAF77}"/>
               </a:ext>
             </a:extLst>
           </p:cNvPr>
@@ -2360,7 +2361,7 @@
           <p:cNvPr id="5" name="Datumsplatzhalter 4">
             <a:extLst>
               <a:ext uri="{FF2B5EF4-FFF2-40B4-BE49-F238E27FC236}">
-                <a16:creationId xmlns:a16="http://schemas.microsoft.com/office/drawing/2014/main" id="{F0E24507-EB1B-E465-A24B-FBD30B1F139A}"/>
+                <a16:creationId xmlns:a16="http://schemas.microsoft.com/office/drawing/2014/main" id="{E40BC532-2F99-A23A-23F7-C3D1BB13F89C}"/>
               </a:ext>
             </a:extLst>
           </p:cNvPr>
@@ -2376,7 +2377,7 @@
           <a:bodyPr/>
           <a:lstStyle/>
           <a:p>
-            <a:fld id="{2B2DA3C3-51DF-4EE9-86A1-34325403423E}" type="datetimeFigureOut">
+            <a:fld id="{278CD8EF-D6A2-48A4-B300-6579972A1288}" type="datetimeFigureOut">
               <a:rPr lang="de-DE" smtClean="0"/>
               <a:t>08.10.2026</a:t>
             </a:fld>
@@ -2389,7 +2390,7 @@
           <p:cNvPr id="6" name="Fußzeilenplatzhalter 5">
             <a:extLst>
               <a:ext uri="{FF2B5EF4-FFF2-40B4-BE49-F238E27FC236}">
-                <a16:creationId xmlns:a16="http://schemas.microsoft.com/office/drawing/2014/main" id="{C9B04A97-D159-C581-2CA9-1A17DAE6222E}"/>
+                <a16:creationId xmlns:a16="http://schemas.microsoft.com/office/drawing/2014/main" id="{BFB1B37E-62B6-08E8-735E-BD39190D8775}"/>
               </a:ext>
             </a:extLst>
           </p:cNvPr>
@@ -2414,7 +2415,7 @@
           <p:cNvPr id="7" name="Foliennummernplatzhalter 6">
             <a:extLst>
               <a:ext uri="{FF2B5EF4-FFF2-40B4-BE49-F238E27FC236}">
-                <a16:creationId xmlns:a16="http://schemas.microsoft.com/office/drawing/2014/main" id="{3D7BAE60-4CA5-8367-1210-FFB9EDAE709B}"/>
+                <a16:creationId xmlns:a16="http://schemas.microsoft.com/office/drawing/2014/main" id="{0B42D256-CD82-919B-AA7A-B56582B118DE}"/>
               </a:ext>
             </a:extLst>
           </p:cNvPr>
@@ -2430,7 +2431,7 @@
           <a:bodyPr/>
           <a:lstStyle/>
           <a:p>
-            <a:fld id="{4D70D18B-266E-488B-AD8F-5C6559F88AB1}" type="slidenum">
+            <a:fld id="{7C7A06F6-DCB2-44F2-9195-0F2ECB91F403}" type="slidenum">
               <a:rPr lang="de-DE" smtClean="0"/>
               <a:t>‹Nr.›</a:t>
             </a:fld>
@@ -2441,7 +2442,7 @@
     </p:spTree>
     <p:extLst>
       <p:ext uri="{BB962C8B-B14F-4D97-AF65-F5344CB8AC3E}">
-        <p14:creationId xmlns:p14="http://schemas.microsoft.com/office/powerpoint/2010/main" val="2275145755"/>
+        <p14:creationId xmlns:p14="http://schemas.microsoft.com/office/powerpoint/2010/main" val="1874209958"/>
       </p:ext>
     </p:extLst>
   </p:cSld>
@@ -2473,7 +2474,7 @@
           <p:cNvPr id="2" name="Titel 1">
             <a:extLst>
               <a:ext uri="{FF2B5EF4-FFF2-40B4-BE49-F238E27FC236}">
-                <a16:creationId xmlns:a16="http://schemas.microsoft.com/office/drawing/2014/main" id="{FBAEC0A6-522A-B636-039B-F854F7BC4EC0}"/>
+                <a16:creationId xmlns:a16="http://schemas.microsoft.com/office/drawing/2014/main" id="{AE41D88A-3D0F-F5FF-27E5-A9C6E312BD29}"/>
               </a:ext>
             </a:extLst>
           </p:cNvPr>
@@ -2510,7 +2511,7 @@
           <p:cNvPr id="3" name="Bildplatzhalter 2">
             <a:extLst>
               <a:ext uri="{FF2B5EF4-FFF2-40B4-BE49-F238E27FC236}">
-                <a16:creationId xmlns:a16="http://schemas.microsoft.com/office/drawing/2014/main" id="{61086BAB-4D9B-DA14-CB7D-2A85A363F15A}"/>
+                <a16:creationId xmlns:a16="http://schemas.microsoft.com/office/drawing/2014/main" id="{CDB38CA0-A6C3-1B65-188D-6D62AD880BD1}"/>
               </a:ext>
             </a:extLst>
           </p:cNvPr>
@@ -2577,7 +2578,7 @@
           <p:cNvPr id="4" name="Textplatzhalter 3">
             <a:extLst>
               <a:ext uri="{FF2B5EF4-FFF2-40B4-BE49-F238E27FC236}">
-                <a16:creationId xmlns:a16="http://schemas.microsoft.com/office/drawing/2014/main" id="{40262C05-6955-C741-C2EB-5A9984CC6BDE}"/>
+                <a16:creationId xmlns:a16="http://schemas.microsoft.com/office/drawing/2014/main" id="{513E905C-223E-00E1-82F3-CD3EB3D52B3A}"/>
               </a:ext>
             </a:extLst>
           </p:cNvPr>
@@ -2648,7 +2649,7 @@
           <p:cNvPr id="5" name="Datumsplatzhalter 4">
             <a:extLst>
               <a:ext uri="{FF2B5EF4-FFF2-40B4-BE49-F238E27FC236}">
-                <a16:creationId xmlns:a16="http://schemas.microsoft.com/office/drawing/2014/main" id="{4647C114-8164-6D7D-6A53-EA69A9BB5923}"/>
+                <a16:creationId xmlns:a16="http://schemas.microsoft.com/office/drawing/2014/main" id="{3F98E62E-34CF-DE94-336F-15E35B0A20C6}"/>
               </a:ext>
             </a:extLst>
           </p:cNvPr>
@@ -2664,7 +2665,7 @@
           <a:bodyPr/>
           <a:lstStyle/>
           <a:p>
-            <a:fld id="{2B2DA3C3-51DF-4EE9-86A1-34325403423E}" type="datetimeFigureOut">
+            <a:fld id="{278CD8EF-D6A2-48A4-B300-6579972A1288}" type="datetimeFigureOut">
               <a:rPr lang="de-DE" smtClean="0"/>
               <a:t>08.10.2026</a:t>
             </a:fld>
@@ -2677,7 +2678,7 @@
           <p:cNvPr id="6" name="Fußzeilenplatzhalter 5">
             <a:extLst>
               <a:ext uri="{FF2B5EF4-FFF2-40B4-BE49-F238E27FC236}">
-                <a16:creationId xmlns:a16="http://schemas.microsoft.com/office/drawing/2014/main" id="{862C52C6-CBBF-CEB5-67EE-CCF1C48CC4BB}"/>
+                <a16:creationId xmlns:a16="http://schemas.microsoft.com/office/drawing/2014/main" id="{4DEEE473-453F-C9F5-A86A-E9C88346A8D1}"/>
               </a:ext>
             </a:extLst>
           </p:cNvPr>
@@ -2702,7 +2703,7 @@
           <p:cNvPr id="7" name="Foliennummernplatzhalter 6">
             <a:extLst>
               <a:ext uri="{FF2B5EF4-FFF2-40B4-BE49-F238E27FC236}">
-                <a16:creationId xmlns:a16="http://schemas.microsoft.com/office/drawing/2014/main" id="{DBDD14BE-2137-FC2D-A8FB-AFA037E28EFE}"/>
+                <a16:creationId xmlns:a16="http://schemas.microsoft.com/office/drawing/2014/main" id="{3F3E7860-E52D-5872-C96C-0A8A63BD89BA}"/>
               </a:ext>
             </a:extLst>
           </p:cNvPr>
@@ -2718,7 +2719,7 @@
           <a:bodyPr/>
           <a:lstStyle/>
           <a:p>
-            <a:fld id="{4D70D18B-266E-488B-AD8F-5C6559F88AB1}" type="slidenum">
+            <a:fld id="{7C7A06F6-DCB2-44F2-9195-0F2ECB91F403}" type="slidenum">
               <a:rPr lang="de-DE" smtClean="0"/>
               <a:t>‹Nr.›</a:t>
             </a:fld>
@@ -2729,7 +2730,7 @@
     </p:spTree>
     <p:extLst>
       <p:ext uri="{BB962C8B-B14F-4D97-AF65-F5344CB8AC3E}">
-        <p14:creationId xmlns:p14="http://schemas.microsoft.com/office/powerpoint/2010/main" val="3761723995"/>
+        <p14:creationId xmlns:p14="http://schemas.microsoft.com/office/powerpoint/2010/main" val="2583098329"/>
       </p:ext>
     </p:extLst>
   </p:cSld>
@@ -2766,7 +2767,7 @@
           <p:cNvPr id="2" name="Titelplatzhalter 1">
             <a:extLst>
               <a:ext uri="{FF2B5EF4-FFF2-40B4-BE49-F238E27FC236}">
-                <a16:creationId xmlns:a16="http://schemas.microsoft.com/office/drawing/2014/main" id="{8F7C9E83-A54D-CC07-7F2C-DED107DD90A6}"/>
+                <a16:creationId xmlns:a16="http://schemas.microsoft.com/office/drawing/2014/main" id="{C79F1479-D317-D974-2F50-3E1EED1E4EA4}"/>
               </a:ext>
             </a:extLst>
           </p:cNvPr>
@@ -2804,7 +2805,7 @@
           <p:cNvPr id="3" name="Textplatzhalter 2">
             <a:extLst>
               <a:ext uri="{FF2B5EF4-FFF2-40B4-BE49-F238E27FC236}">
-                <a16:creationId xmlns:a16="http://schemas.microsoft.com/office/drawing/2014/main" id="{5912BF4A-986C-C637-74D0-A9F977CBC5B2}"/>
+                <a16:creationId xmlns:a16="http://schemas.microsoft.com/office/drawing/2014/main" id="{ABF33F74-EE18-17DB-8A3C-7C9354BB642D}"/>
               </a:ext>
             </a:extLst>
           </p:cNvPr>
@@ -2871,7 +2872,7 @@
           <p:cNvPr id="4" name="Datumsplatzhalter 3">
             <a:extLst>
               <a:ext uri="{FF2B5EF4-FFF2-40B4-BE49-F238E27FC236}">
-                <a16:creationId xmlns:a16="http://schemas.microsoft.com/office/drawing/2014/main" id="{69DCE41E-5372-F7F1-B433-61902FEDF86E}"/>
+                <a16:creationId xmlns:a16="http://schemas.microsoft.com/office/drawing/2014/main" id="{AD61741F-0D2D-AB7E-4BDC-E62CDDE46AC9}"/>
               </a:ext>
             </a:extLst>
           </p:cNvPr>
@@ -2905,7 +2906,7 @@
             </a:lvl1pPr>
           </a:lstStyle>
           <a:p>
-            <a:fld id="{2B2DA3C3-51DF-4EE9-86A1-34325403423E}" type="datetimeFigureOut">
+            <a:fld id="{278CD8EF-D6A2-48A4-B300-6579972A1288}" type="datetimeFigureOut">
               <a:rPr lang="de-DE" smtClean="0"/>
               <a:t>08.10.2026</a:t>
             </a:fld>
@@ -2918,7 +2919,7 @@
           <p:cNvPr id="5" name="Fußzeilenplatzhalter 4">
             <a:extLst>
               <a:ext uri="{FF2B5EF4-FFF2-40B4-BE49-F238E27FC236}">
-                <a16:creationId xmlns:a16="http://schemas.microsoft.com/office/drawing/2014/main" id="{CAB5A3EB-960A-9B3D-815C-AE350B7961E0}"/>
+                <a16:creationId xmlns:a16="http://schemas.microsoft.com/office/drawing/2014/main" id="{835FC8FA-B5A4-8132-5224-A8D40AC2289C}"/>
               </a:ext>
             </a:extLst>
           </p:cNvPr>
@@ -2961,7 +2962,7 @@
           <p:cNvPr id="6" name="Foliennummernplatzhalter 5">
             <a:extLst>
               <a:ext uri="{FF2B5EF4-FFF2-40B4-BE49-F238E27FC236}">
-                <a16:creationId xmlns:a16="http://schemas.microsoft.com/office/drawing/2014/main" id="{FF55C9D6-3D14-A08F-1DC3-DDA4A47E6459}"/>
+                <a16:creationId xmlns:a16="http://schemas.microsoft.com/office/drawing/2014/main" id="{42210A2A-B940-55EF-42F6-1C6B34613FE8}"/>
               </a:ext>
             </a:extLst>
           </p:cNvPr>
@@ -2995,7 +2996,7 @@
             </a:lvl1pPr>
           </a:lstStyle>
           <a:p>
-            <a:fld id="{4D70D18B-266E-488B-AD8F-5C6559F88AB1}" type="slidenum">
+            <a:fld id="{7C7A06F6-DCB2-44F2-9195-0F2ECB91F403}" type="slidenum">
               <a:rPr lang="de-DE" smtClean="0"/>
               <a:t>‹Nr.›</a:t>
             </a:fld>
@@ -3006,7 +3007,7 @@
     </p:spTree>
     <p:extLst>
       <p:ext uri="{BB962C8B-B14F-4D97-AF65-F5344CB8AC3E}">
-        <p14:creationId xmlns:p14="http://schemas.microsoft.com/office/powerpoint/2010/main" val="1671059046"/>
+        <p14:creationId xmlns:p14="http://schemas.microsoft.com/office/powerpoint/2010/main" val="3482050886"/>
       </p:ext>
     </p:extLst>
   </p:cSld>
@@ -3329,7 +3330,7 @@
           <p:cNvPr id="2" name="Tabelle 1">
             <a:extLst>
               <a:ext uri="{FF2B5EF4-FFF2-40B4-BE49-F238E27FC236}">
-                <a16:creationId xmlns:a16="http://schemas.microsoft.com/office/drawing/2014/main" id="{C3CCE5B2-D6E5-BE2E-2903-F457B5ED79CE}"/>
+                <a16:creationId xmlns:a16="http://schemas.microsoft.com/office/drawing/2014/main" id="{3D03EF30-E854-10EB-4EEC-64B9AAFF8A7F}"/>
               </a:ext>
             </a:extLst>
           </p:cNvPr>
@@ -3339,7 +3340,7 @@
           <p:nvPr>
             <p:extLst>
               <p:ext uri="{D42A27DB-BD31-4B8C-83A1-F6EECF244321}">
-                <p14:modId xmlns:p14="http://schemas.microsoft.com/office/powerpoint/2010/main" val="2931429834"/>
+                <p14:modId xmlns:p14="http://schemas.microsoft.com/office/powerpoint/2010/main" val="2435542894"/>
               </p:ext>
             </p:extLst>
           </p:nvPr>
@@ -3358,21 +3359,21 @@
                 <a:gridCol w="1820333">
                   <a:extLst>
                     <a:ext uri="{9D8B030D-6E8A-4147-A177-3AD203B41FA5}">
-                      <a16:colId xmlns:a16="http://schemas.microsoft.com/office/drawing/2014/main" val="2891003596"/>
+                      <a16:colId xmlns:a16="http://schemas.microsoft.com/office/drawing/2014/main" val="2506257352"/>
                     </a:ext>
                   </a:extLst>
                 </a:gridCol>
                 <a:gridCol w="1820333">
                   <a:extLst>
                     <a:ext uri="{9D8B030D-6E8A-4147-A177-3AD203B41FA5}">
-                      <a16:colId xmlns:a16="http://schemas.microsoft.com/office/drawing/2014/main" val="363934254"/>
+                      <a16:colId xmlns:a16="http://schemas.microsoft.com/office/drawing/2014/main" val="1950816056"/>
                     </a:ext>
                   </a:extLst>
                 </a:gridCol>
                 <a:gridCol w="1820333">
                   <a:extLst>
                     <a:ext uri="{9D8B030D-6E8A-4147-A177-3AD203B41FA5}">
-                      <a16:colId xmlns:a16="http://schemas.microsoft.com/office/drawing/2014/main" val="993690114"/>
+                      <a16:colId xmlns:a16="http://schemas.microsoft.com/office/drawing/2014/main" val="2139231231"/>
                     </a:ext>
                   </a:extLst>
                 </a:gridCol>
@@ -3419,7 +3420,7 @@
                 </a:tc>
                 <a:extLst>
                   <a:ext uri="{0D108BD9-81ED-4DB2-BD59-A6C34878D82A}">
-                    <a16:rowId xmlns:a16="http://schemas.microsoft.com/office/drawing/2014/main" val="705280993"/>
+                    <a16:rowId xmlns:a16="http://schemas.microsoft.com/office/drawing/2014/main" val="2557171294"/>
                   </a:ext>
                 </a:extLst>
               </a:tr>
@@ -3465,7 +3466,7 @@
                 </a:tc>
                 <a:extLst>
                   <a:ext uri="{0D108BD9-81ED-4DB2-BD59-A6C34878D82A}">
-                    <a16:rowId xmlns:a16="http://schemas.microsoft.com/office/drawing/2014/main" val="2949106873"/>
+                    <a16:rowId xmlns:a16="http://schemas.microsoft.com/office/drawing/2014/main" val="3333765860"/>
                   </a:ext>
                 </a:extLst>
               </a:tr>
@@ -3511,7 +3512,7 @@
                 </a:tc>
                 <a:extLst>
                   <a:ext uri="{0D108BD9-81ED-4DB2-BD59-A6C34878D82A}">
-                    <a16:rowId xmlns:a16="http://schemas.microsoft.com/office/drawing/2014/main" val="908502838"/>
+                    <a16:rowId xmlns:a16="http://schemas.microsoft.com/office/drawing/2014/main" val="538508647"/>
                   </a:ext>
                 </a:extLst>
               </a:tr>
@@ -3557,7 +3558,7 @@
                 </a:tc>
                 <a:extLst>
                   <a:ext uri="{0D108BD9-81ED-4DB2-BD59-A6C34878D82A}">
-                    <a16:rowId xmlns:a16="http://schemas.microsoft.com/office/drawing/2014/main" val="2764050906"/>
+                    <a16:rowId xmlns:a16="http://schemas.microsoft.com/office/drawing/2014/main" val="2714857151"/>
                   </a:ext>
                 </a:extLst>
               </a:tr>
@@ -3570,7 +3571,7 @@
           <p:cNvPr id="3" name="Tabelle 2">
             <a:extLst>
               <a:ext uri="{FF2B5EF4-FFF2-40B4-BE49-F238E27FC236}">
-                <a16:creationId xmlns:a16="http://schemas.microsoft.com/office/drawing/2014/main" id="{874D6DF3-0360-99C5-EABA-6EA7D3400355}"/>
+                <a16:creationId xmlns:a16="http://schemas.microsoft.com/office/drawing/2014/main" id="{80E47FCC-9E3E-4628-AB79-802FDE14CFCE}"/>
               </a:ext>
             </a:extLst>
           </p:cNvPr>
@@ -3580,7 +3581,7 @@
           <p:nvPr>
             <p:extLst>
               <p:ext uri="{D42A27DB-BD31-4B8C-83A1-F6EECF244321}">
-                <p14:modId xmlns:p14="http://schemas.microsoft.com/office/powerpoint/2010/main" val="728570613"/>
+                <p14:modId xmlns:p14="http://schemas.microsoft.com/office/powerpoint/2010/main" val="3430939803"/>
               </p:ext>
             </p:extLst>
           </p:nvPr>
@@ -3599,21 +3600,21 @@
                 <a:gridCol w="1820333">
                   <a:extLst>
                     <a:ext uri="{9D8B030D-6E8A-4147-A177-3AD203B41FA5}">
-                      <a16:colId xmlns:a16="http://schemas.microsoft.com/office/drawing/2014/main" val="2425920554"/>
+                      <a16:colId xmlns:a16="http://schemas.microsoft.com/office/drawing/2014/main" val="4005037166"/>
                     </a:ext>
                   </a:extLst>
                 </a:gridCol>
                 <a:gridCol w="1820333">
                   <a:extLst>
                     <a:ext uri="{9D8B030D-6E8A-4147-A177-3AD203B41FA5}">
-                      <a16:colId xmlns:a16="http://schemas.microsoft.com/office/drawing/2014/main" val="281172817"/>
+                      <a16:colId xmlns:a16="http://schemas.microsoft.com/office/drawing/2014/main" val="3986967671"/>
                     </a:ext>
                   </a:extLst>
                 </a:gridCol>
                 <a:gridCol w="1820333">
                   <a:extLst>
                     <a:ext uri="{9D8B030D-6E8A-4147-A177-3AD203B41FA5}">
-                      <a16:colId xmlns:a16="http://schemas.microsoft.com/office/drawing/2014/main" val="3542014791"/>
+                      <a16:colId xmlns:a16="http://schemas.microsoft.com/office/drawing/2014/main" val="1812142517"/>
                     </a:ext>
                   </a:extLst>
                 </a:gridCol>
@@ -3660,7 +3661,7 @@
                 </a:tc>
                 <a:extLst>
                   <a:ext uri="{0D108BD9-81ED-4DB2-BD59-A6C34878D82A}">
-                    <a16:rowId xmlns:a16="http://schemas.microsoft.com/office/drawing/2014/main" val="1955337515"/>
+                    <a16:rowId xmlns:a16="http://schemas.microsoft.com/office/drawing/2014/main" val="542348643"/>
                   </a:ext>
                 </a:extLst>
               </a:tr>
@@ -3706,7 +3707,7 @@
                 </a:tc>
                 <a:extLst>
                   <a:ext uri="{0D108BD9-81ED-4DB2-BD59-A6C34878D82A}">
-                    <a16:rowId xmlns:a16="http://schemas.microsoft.com/office/drawing/2014/main" val="4006605294"/>
+                    <a16:rowId xmlns:a16="http://schemas.microsoft.com/office/drawing/2014/main" val="2257233089"/>
                   </a:ext>
                 </a:extLst>
               </a:tr>
@@ -3752,7 +3753,7 @@
                 </a:tc>
                 <a:extLst>
                   <a:ext uri="{0D108BD9-81ED-4DB2-BD59-A6C34878D82A}">
-                    <a16:rowId xmlns:a16="http://schemas.microsoft.com/office/drawing/2014/main" val="935270625"/>
+                    <a16:rowId xmlns:a16="http://schemas.microsoft.com/office/drawing/2014/main" val="1759175887"/>
                   </a:ext>
                 </a:extLst>
               </a:tr>
@@ -3798,7 +3799,7 @@
                 </a:tc>
                 <a:extLst>
                   <a:ext uri="{0D108BD9-81ED-4DB2-BD59-A6C34878D82A}">
-                    <a16:rowId xmlns:a16="http://schemas.microsoft.com/office/drawing/2014/main" val="3671772526"/>
+                    <a16:rowId xmlns:a16="http://schemas.microsoft.com/office/drawing/2014/main" val="1702181431"/>
                   </a:ext>
                 </a:extLst>
               </a:tr>
@@ -3811,7 +3812,7 @@
           <p:cNvPr id="4" name="Tabelle 3">
             <a:extLst>
               <a:ext uri="{FF2B5EF4-FFF2-40B4-BE49-F238E27FC236}">
-                <a16:creationId xmlns:a16="http://schemas.microsoft.com/office/drawing/2014/main" id="{CEDF5A23-8952-2266-CD95-583B91C2C7D4}"/>
+                <a16:creationId xmlns:a16="http://schemas.microsoft.com/office/drawing/2014/main" id="{DEB4A477-7F5A-C4C4-57B1-169C9FB10137}"/>
               </a:ext>
             </a:extLst>
           </p:cNvPr>
@@ -3821,7 +3822,7 @@
           <p:nvPr>
             <p:extLst>
               <p:ext uri="{D42A27DB-BD31-4B8C-83A1-F6EECF244321}">
-                <p14:modId xmlns:p14="http://schemas.microsoft.com/office/powerpoint/2010/main" val="3733499940"/>
+                <p14:modId xmlns:p14="http://schemas.microsoft.com/office/powerpoint/2010/main" val="2567684999"/>
               </p:ext>
             </p:extLst>
           </p:nvPr>
@@ -3840,21 +3841,21 @@
                 <a:gridCol w="1820333">
                   <a:extLst>
                     <a:ext uri="{9D8B030D-6E8A-4147-A177-3AD203B41FA5}">
-                      <a16:colId xmlns:a16="http://schemas.microsoft.com/office/drawing/2014/main" val="4091855188"/>
+                      <a16:colId xmlns:a16="http://schemas.microsoft.com/office/drawing/2014/main" val="60212023"/>
                     </a:ext>
                   </a:extLst>
                 </a:gridCol>
                 <a:gridCol w="1820333">
                   <a:extLst>
                     <a:ext uri="{9D8B030D-6E8A-4147-A177-3AD203B41FA5}">
-                      <a16:colId xmlns:a16="http://schemas.microsoft.com/office/drawing/2014/main" val="597995934"/>
+                      <a16:colId xmlns:a16="http://schemas.microsoft.com/office/drawing/2014/main" val="371849200"/>
                     </a:ext>
                   </a:extLst>
                 </a:gridCol>
                 <a:gridCol w="1820333">
                   <a:extLst>
                     <a:ext uri="{9D8B030D-6E8A-4147-A177-3AD203B41FA5}">
-                      <a16:colId xmlns:a16="http://schemas.microsoft.com/office/drawing/2014/main" val="3339141265"/>
+                      <a16:colId xmlns:a16="http://schemas.microsoft.com/office/drawing/2014/main" val="4175102835"/>
                     </a:ext>
                   </a:extLst>
                 </a:gridCol>
@@ -3901,7 +3902,7 @@
                 </a:tc>
                 <a:extLst>
                   <a:ext uri="{0D108BD9-81ED-4DB2-BD59-A6C34878D82A}">
-                    <a16:rowId xmlns:a16="http://schemas.microsoft.com/office/drawing/2014/main" val="1318870978"/>
+                    <a16:rowId xmlns:a16="http://schemas.microsoft.com/office/drawing/2014/main" val="3438881053"/>
                   </a:ext>
                 </a:extLst>
               </a:tr>
@@ -3947,7 +3948,7 @@
                 </a:tc>
                 <a:extLst>
                   <a:ext uri="{0D108BD9-81ED-4DB2-BD59-A6C34878D82A}">
-                    <a16:rowId xmlns:a16="http://schemas.microsoft.com/office/drawing/2014/main" val="2326198870"/>
+                    <a16:rowId xmlns:a16="http://schemas.microsoft.com/office/drawing/2014/main" val="2145641932"/>
                   </a:ext>
                 </a:extLst>
               </a:tr>
@@ -3993,7 +3994,7 @@
                 </a:tc>
                 <a:extLst>
                   <a:ext uri="{0D108BD9-81ED-4DB2-BD59-A6C34878D82A}">
-                    <a16:rowId xmlns:a16="http://schemas.microsoft.com/office/drawing/2014/main" val="2666084966"/>
+                    <a16:rowId xmlns:a16="http://schemas.microsoft.com/office/drawing/2014/main" val="2125852146"/>
                   </a:ext>
                 </a:extLst>
               </a:tr>
@@ -4039,7 +4040,7 @@
                 </a:tc>
                 <a:extLst>
                   <a:ext uri="{0D108BD9-81ED-4DB2-BD59-A6C34878D82A}">
-                    <a16:rowId xmlns:a16="http://schemas.microsoft.com/office/drawing/2014/main" val="3399383465"/>
+                    <a16:rowId xmlns:a16="http://schemas.microsoft.com/office/drawing/2014/main" val="256097275"/>
                   </a:ext>
                 </a:extLst>
               </a:tr>
@@ -4052,7 +4053,7 @@
           <p:cNvPr id="5" name="Tabelle 4">
             <a:extLst>
               <a:ext uri="{FF2B5EF4-FFF2-40B4-BE49-F238E27FC236}">
-                <a16:creationId xmlns:a16="http://schemas.microsoft.com/office/drawing/2014/main" id="{72AF2E37-9608-DF6D-A13B-A4FA65C816DE}"/>
+                <a16:creationId xmlns:a16="http://schemas.microsoft.com/office/drawing/2014/main" id="{B58AA97E-D2EE-A3B4-BA30-F8CE74ECB73D}"/>
               </a:ext>
             </a:extLst>
           </p:cNvPr>
@@ -4062,7 +4063,7 @@
           <p:nvPr>
             <p:extLst>
               <p:ext uri="{D42A27DB-BD31-4B8C-83A1-F6EECF244321}">
-                <p14:modId xmlns:p14="http://schemas.microsoft.com/office/powerpoint/2010/main" val="3320578188"/>
+                <p14:modId xmlns:p14="http://schemas.microsoft.com/office/powerpoint/2010/main" val="2202695908"/>
               </p:ext>
             </p:extLst>
           </p:nvPr>
@@ -4081,21 +4082,21 @@
                 <a:gridCol w="1820333">
                   <a:extLst>
                     <a:ext uri="{9D8B030D-6E8A-4147-A177-3AD203B41FA5}">
-                      <a16:colId xmlns:a16="http://schemas.microsoft.com/office/drawing/2014/main" val="2466653158"/>
+                      <a16:colId xmlns:a16="http://schemas.microsoft.com/office/drawing/2014/main" val="1655559505"/>
                     </a:ext>
                   </a:extLst>
                 </a:gridCol>
                 <a:gridCol w="1820333">
                   <a:extLst>
                     <a:ext uri="{9D8B030D-6E8A-4147-A177-3AD203B41FA5}">
-                      <a16:colId xmlns:a16="http://schemas.microsoft.com/office/drawing/2014/main" val="3013858495"/>
+                      <a16:colId xmlns:a16="http://schemas.microsoft.com/office/drawing/2014/main" val="3289792871"/>
                     </a:ext>
                   </a:extLst>
                 </a:gridCol>
                 <a:gridCol w="1820333">
                   <a:extLst>
                     <a:ext uri="{9D8B030D-6E8A-4147-A177-3AD203B41FA5}">
-                      <a16:colId xmlns:a16="http://schemas.microsoft.com/office/drawing/2014/main" val="2411525"/>
+                      <a16:colId xmlns:a16="http://schemas.microsoft.com/office/drawing/2014/main" val="4198219828"/>
                     </a:ext>
                   </a:extLst>
                 </a:gridCol>
@@ -4142,7 +4143,7 @@
                 </a:tc>
                 <a:extLst>
                   <a:ext uri="{0D108BD9-81ED-4DB2-BD59-A6C34878D82A}">
-                    <a16:rowId xmlns:a16="http://schemas.microsoft.com/office/drawing/2014/main" val="198310135"/>
+                    <a16:rowId xmlns:a16="http://schemas.microsoft.com/office/drawing/2014/main" val="2459448275"/>
                   </a:ext>
                 </a:extLst>
               </a:tr>
@@ -4188,7 +4189,7 @@
                 </a:tc>
                 <a:extLst>
                   <a:ext uri="{0D108BD9-81ED-4DB2-BD59-A6C34878D82A}">
-                    <a16:rowId xmlns:a16="http://schemas.microsoft.com/office/drawing/2014/main" val="452271212"/>
+                    <a16:rowId xmlns:a16="http://schemas.microsoft.com/office/drawing/2014/main" val="4019688455"/>
                   </a:ext>
                 </a:extLst>
               </a:tr>
@@ -4234,7 +4235,7 @@
                 </a:tc>
                 <a:extLst>
                   <a:ext uri="{0D108BD9-81ED-4DB2-BD59-A6C34878D82A}">
-                    <a16:rowId xmlns:a16="http://schemas.microsoft.com/office/drawing/2014/main" val="861526056"/>
+                    <a16:rowId xmlns:a16="http://schemas.microsoft.com/office/drawing/2014/main" val="3546412178"/>
                   </a:ext>
                 </a:extLst>
               </a:tr>
@@ -4280,7 +4281,7 @@
                 </a:tc>
                 <a:extLst>
                   <a:ext uri="{0D108BD9-81ED-4DB2-BD59-A6C34878D82A}">
-                    <a16:rowId xmlns:a16="http://schemas.microsoft.com/office/drawing/2014/main" val="3421674074"/>
+                    <a16:rowId xmlns:a16="http://schemas.microsoft.com/office/drawing/2014/main" val="3892118650"/>
                   </a:ext>
                 </a:extLst>
               </a:tr>
@@ -4291,7 +4292,7 @@
     </p:spTree>
     <p:extLst>
       <p:ext uri="{BB962C8B-B14F-4D97-AF65-F5344CB8AC3E}">
-        <p14:creationId xmlns:p14="http://schemas.microsoft.com/office/powerpoint/2010/main" val="273426582"/>
+        <p14:creationId xmlns:p14="http://schemas.microsoft.com/office/powerpoint/2010/main" val="4278324869"/>
       </p:ext>
     </p:extLst>
   </p:cSld>
@@ -4323,7 +4324,7 @@
           <p:cNvPr id="2" name="Tabelle 1">
             <a:extLst>
               <a:ext uri="{FF2B5EF4-FFF2-40B4-BE49-F238E27FC236}">
-                <a16:creationId xmlns:a16="http://schemas.microsoft.com/office/drawing/2014/main" id="{09EC3DC2-7C14-F443-B918-B7288B7B57AD}"/>
+                <a16:creationId xmlns:a16="http://schemas.microsoft.com/office/drawing/2014/main" id="{89B61F7C-A078-F115-105D-1340F6EEBFED}"/>
               </a:ext>
             </a:extLst>
           </p:cNvPr>
@@ -4333,7 +4334,7 @@
           <p:nvPr>
             <p:extLst>
               <p:ext uri="{D42A27DB-BD31-4B8C-83A1-F6EECF244321}">
-                <p14:modId xmlns:p14="http://schemas.microsoft.com/office/powerpoint/2010/main" val="2505311556"/>
+                <p14:modId xmlns:p14="http://schemas.microsoft.com/office/powerpoint/2010/main" val="2245718542"/>
               </p:ext>
             </p:extLst>
           </p:nvPr>
@@ -4352,21 +4353,21 @@
                 <a:gridCol w="1820333">
                   <a:extLst>
                     <a:ext uri="{9D8B030D-6E8A-4147-A177-3AD203B41FA5}">
-                      <a16:colId xmlns:a16="http://schemas.microsoft.com/office/drawing/2014/main" val="665779275"/>
+                      <a16:colId xmlns:a16="http://schemas.microsoft.com/office/drawing/2014/main" val="1858798744"/>
                     </a:ext>
                   </a:extLst>
                 </a:gridCol>
                 <a:gridCol w="1820333">
                   <a:extLst>
                     <a:ext uri="{9D8B030D-6E8A-4147-A177-3AD203B41FA5}">
-                      <a16:colId xmlns:a16="http://schemas.microsoft.com/office/drawing/2014/main" val="963532456"/>
+                      <a16:colId xmlns:a16="http://schemas.microsoft.com/office/drawing/2014/main" val="3119186661"/>
                     </a:ext>
                   </a:extLst>
                 </a:gridCol>
                 <a:gridCol w="1820333">
                   <a:extLst>
                     <a:ext uri="{9D8B030D-6E8A-4147-A177-3AD203B41FA5}">
-                      <a16:colId xmlns:a16="http://schemas.microsoft.com/office/drawing/2014/main" val="566618321"/>
+                      <a16:colId xmlns:a16="http://schemas.microsoft.com/office/drawing/2014/main" val="4288659805"/>
                     </a:ext>
                   </a:extLst>
                 </a:gridCol>
@@ -4413,7 +4414,7 @@
                 </a:tc>
                 <a:extLst>
                   <a:ext uri="{0D108BD9-81ED-4DB2-BD59-A6C34878D82A}">
-                    <a16:rowId xmlns:a16="http://schemas.microsoft.com/office/drawing/2014/main" val="2230048090"/>
+                    <a16:rowId xmlns:a16="http://schemas.microsoft.com/office/drawing/2014/main" val="2027263595"/>
                   </a:ext>
                 </a:extLst>
               </a:tr>
@@ -4459,7 +4460,7 @@
                 </a:tc>
                 <a:extLst>
                   <a:ext uri="{0D108BD9-81ED-4DB2-BD59-A6C34878D82A}">
-                    <a16:rowId xmlns:a16="http://schemas.microsoft.com/office/drawing/2014/main" val="3385654508"/>
+                    <a16:rowId xmlns:a16="http://schemas.microsoft.com/office/drawing/2014/main" val="3169064994"/>
                   </a:ext>
                 </a:extLst>
               </a:tr>
@@ -4505,7 +4506,7 @@
                 </a:tc>
                 <a:extLst>
                   <a:ext uri="{0D108BD9-81ED-4DB2-BD59-A6C34878D82A}">
-                    <a16:rowId xmlns:a16="http://schemas.microsoft.com/office/drawing/2014/main" val="297443161"/>
+                    <a16:rowId xmlns:a16="http://schemas.microsoft.com/office/drawing/2014/main" val="4103225223"/>
                   </a:ext>
                 </a:extLst>
               </a:tr>
@@ -4551,7 +4552,7 @@
                 </a:tc>
                 <a:extLst>
                   <a:ext uri="{0D108BD9-81ED-4DB2-BD59-A6C34878D82A}">
-                    <a16:rowId xmlns:a16="http://schemas.microsoft.com/office/drawing/2014/main" val="535751203"/>
+                    <a16:rowId xmlns:a16="http://schemas.microsoft.com/office/drawing/2014/main" val="3556356000"/>
                   </a:ext>
                 </a:extLst>
               </a:tr>
@@ -4564,7 +4565,7 @@
           <p:cNvPr id="3" name="Tabelle 2">
             <a:extLst>
               <a:ext uri="{FF2B5EF4-FFF2-40B4-BE49-F238E27FC236}">
-                <a16:creationId xmlns:a16="http://schemas.microsoft.com/office/drawing/2014/main" id="{24435FDC-4C76-84BE-57FD-6C99C5E503D3}"/>
+                <a16:creationId xmlns:a16="http://schemas.microsoft.com/office/drawing/2014/main" id="{552D1E7F-5E31-BBDF-CA8F-0D5E7A8AA7B1}"/>
               </a:ext>
             </a:extLst>
           </p:cNvPr>
@@ -4574,7 +4575,7 @@
           <p:nvPr>
             <p:extLst>
               <p:ext uri="{D42A27DB-BD31-4B8C-83A1-F6EECF244321}">
-                <p14:modId xmlns:p14="http://schemas.microsoft.com/office/powerpoint/2010/main" val="3703596066"/>
+                <p14:modId xmlns:p14="http://schemas.microsoft.com/office/powerpoint/2010/main" val="3947447564"/>
               </p:ext>
             </p:extLst>
           </p:nvPr>
@@ -4593,21 +4594,21 @@
                 <a:gridCol w="1820333">
                   <a:extLst>
                     <a:ext uri="{9D8B030D-6E8A-4147-A177-3AD203B41FA5}">
-                      <a16:colId xmlns:a16="http://schemas.microsoft.com/office/drawing/2014/main" val="2370831160"/>
+                      <a16:colId xmlns:a16="http://schemas.microsoft.com/office/drawing/2014/main" val="509879161"/>
                     </a:ext>
                   </a:extLst>
                 </a:gridCol>
                 <a:gridCol w="1820333">
                   <a:extLst>
                     <a:ext uri="{9D8B030D-6E8A-4147-A177-3AD203B41FA5}">
-                      <a16:colId xmlns:a16="http://schemas.microsoft.com/office/drawing/2014/main" val="2000015714"/>
+                      <a16:colId xmlns:a16="http://schemas.microsoft.com/office/drawing/2014/main" val="1153733925"/>
                     </a:ext>
                   </a:extLst>
                 </a:gridCol>
                 <a:gridCol w="1820333">
                   <a:extLst>
                     <a:ext uri="{9D8B030D-6E8A-4147-A177-3AD203B41FA5}">
-                      <a16:colId xmlns:a16="http://schemas.microsoft.com/office/drawing/2014/main" val="2769095346"/>
+                      <a16:colId xmlns:a16="http://schemas.microsoft.com/office/drawing/2014/main" val="224835079"/>
                     </a:ext>
                   </a:extLst>
                 </a:gridCol>
@@ -4654,7 +4655,7 @@
                 </a:tc>
                 <a:extLst>
                   <a:ext uri="{0D108BD9-81ED-4DB2-BD59-A6C34878D82A}">
-                    <a16:rowId xmlns:a16="http://schemas.microsoft.com/office/drawing/2014/main" val="247396344"/>
+                    <a16:rowId xmlns:a16="http://schemas.microsoft.com/office/drawing/2014/main" val="2671585553"/>
                   </a:ext>
                 </a:extLst>
               </a:tr>
@@ -4700,7 +4701,7 @@
                 </a:tc>
                 <a:extLst>
                   <a:ext uri="{0D108BD9-81ED-4DB2-BD59-A6C34878D82A}">
-                    <a16:rowId xmlns:a16="http://schemas.microsoft.com/office/drawing/2014/main" val="218968495"/>
+                    <a16:rowId xmlns:a16="http://schemas.microsoft.com/office/drawing/2014/main" val="832441172"/>
                   </a:ext>
                 </a:extLst>
               </a:tr>
@@ -4746,7 +4747,7 @@
                 </a:tc>
                 <a:extLst>
                   <a:ext uri="{0D108BD9-81ED-4DB2-BD59-A6C34878D82A}">
-                    <a16:rowId xmlns:a16="http://schemas.microsoft.com/office/drawing/2014/main" val="1791534943"/>
+                    <a16:rowId xmlns:a16="http://schemas.microsoft.com/office/drawing/2014/main" val="3362505035"/>
                   </a:ext>
                 </a:extLst>
               </a:tr>
@@ -4792,7 +4793,7 @@
                 </a:tc>
                 <a:extLst>
                   <a:ext uri="{0D108BD9-81ED-4DB2-BD59-A6C34878D82A}">
-                    <a16:rowId xmlns:a16="http://schemas.microsoft.com/office/drawing/2014/main" val="1446902545"/>
+                    <a16:rowId xmlns:a16="http://schemas.microsoft.com/office/drawing/2014/main" val="4265260780"/>
                   </a:ext>
                 </a:extLst>
               </a:tr>
@@ -4805,7 +4806,7 @@
           <p:cNvPr id="4" name="Tabelle 3">
             <a:extLst>
               <a:ext uri="{FF2B5EF4-FFF2-40B4-BE49-F238E27FC236}">
-                <a16:creationId xmlns:a16="http://schemas.microsoft.com/office/drawing/2014/main" id="{3F7E7F61-818F-52D0-7445-EF4F0E3117BA}"/>
+                <a16:creationId xmlns:a16="http://schemas.microsoft.com/office/drawing/2014/main" id="{D298A866-4F69-A54E-2761-6D67120C3725}"/>
               </a:ext>
             </a:extLst>
           </p:cNvPr>
@@ -4815,7 +4816,7 @@
           <p:nvPr>
             <p:extLst>
               <p:ext uri="{D42A27DB-BD31-4B8C-83A1-F6EECF244321}">
-                <p14:modId xmlns:p14="http://schemas.microsoft.com/office/powerpoint/2010/main" val="1679291164"/>
+                <p14:modId xmlns:p14="http://schemas.microsoft.com/office/powerpoint/2010/main" val="2931165309"/>
               </p:ext>
             </p:extLst>
           </p:nvPr>
@@ -4834,21 +4835,21 @@
                 <a:gridCol w="1820333">
                   <a:extLst>
                     <a:ext uri="{9D8B030D-6E8A-4147-A177-3AD203B41FA5}">
-                      <a16:colId xmlns:a16="http://schemas.microsoft.com/office/drawing/2014/main" val="4153718091"/>
+                      <a16:colId xmlns:a16="http://schemas.microsoft.com/office/drawing/2014/main" val="1213211754"/>
                     </a:ext>
                   </a:extLst>
                 </a:gridCol>
                 <a:gridCol w="1820333">
                   <a:extLst>
                     <a:ext uri="{9D8B030D-6E8A-4147-A177-3AD203B41FA5}">
-                      <a16:colId xmlns:a16="http://schemas.microsoft.com/office/drawing/2014/main" val="764804452"/>
+                      <a16:colId xmlns:a16="http://schemas.microsoft.com/office/drawing/2014/main" val="3313173442"/>
                     </a:ext>
                   </a:extLst>
                 </a:gridCol>
                 <a:gridCol w="1820333">
                   <a:extLst>
                     <a:ext uri="{9D8B030D-6E8A-4147-A177-3AD203B41FA5}">
-                      <a16:colId xmlns:a16="http://schemas.microsoft.com/office/drawing/2014/main" val="4177375757"/>
+                      <a16:colId xmlns:a16="http://schemas.microsoft.com/office/drawing/2014/main" val="1251229658"/>
                     </a:ext>
                   </a:extLst>
                 </a:gridCol>
@@ -4895,7 +4896,7 @@
                 </a:tc>
                 <a:extLst>
                   <a:ext uri="{0D108BD9-81ED-4DB2-BD59-A6C34878D82A}">
-                    <a16:rowId xmlns:a16="http://schemas.microsoft.com/office/drawing/2014/main" val="3144149324"/>
+                    <a16:rowId xmlns:a16="http://schemas.microsoft.com/office/drawing/2014/main" val="4043832981"/>
                   </a:ext>
                 </a:extLst>
               </a:tr>
@@ -4941,7 +4942,7 @@
                 </a:tc>
                 <a:extLst>
                   <a:ext uri="{0D108BD9-81ED-4DB2-BD59-A6C34878D82A}">
-                    <a16:rowId xmlns:a16="http://schemas.microsoft.com/office/drawing/2014/main" val="1609124123"/>
+                    <a16:rowId xmlns:a16="http://schemas.microsoft.com/office/drawing/2014/main" val="1188473057"/>
                   </a:ext>
                 </a:extLst>
               </a:tr>
@@ -4987,7 +4988,7 @@
                 </a:tc>
                 <a:extLst>
                   <a:ext uri="{0D108BD9-81ED-4DB2-BD59-A6C34878D82A}">
-                    <a16:rowId xmlns:a16="http://schemas.microsoft.com/office/drawing/2014/main" val="3566746053"/>
+                    <a16:rowId xmlns:a16="http://schemas.microsoft.com/office/drawing/2014/main" val="127449995"/>
                   </a:ext>
                 </a:extLst>
               </a:tr>
@@ -5033,7 +5034,7 @@
                 </a:tc>
                 <a:extLst>
                   <a:ext uri="{0D108BD9-81ED-4DB2-BD59-A6C34878D82A}">
-                    <a16:rowId xmlns:a16="http://schemas.microsoft.com/office/drawing/2014/main" val="1903920579"/>
+                    <a16:rowId xmlns:a16="http://schemas.microsoft.com/office/drawing/2014/main" val="1210285248"/>
                   </a:ext>
                 </a:extLst>
               </a:tr>
@@ -5046,7 +5047,7 @@
           <p:cNvPr id="5" name="Tabelle 4">
             <a:extLst>
               <a:ext uri="{FF2B5EF4-FFF2-40B4-BE49-F238E27FC236}">
-                <a16:creationId xmlns:a16="http://schemas.microsoft.com/office/drawing/2014/main" id="{987B22E2-6FCC-D3BA-92D9-706F6A1A38E0}"/>
+                <a16:creationId xmlns:a16="http://schemas.microsoft.com/office/drawing/2014/main" id="{D1C799E7-1FF6-68B1-C5B4-2EA0EEA05612}"/>
               </a:ext>
             </a:extLst>
           </p:cNvPr>
@@ -5056,7 +5057,7 @@
           <p:nvPr>
             <p:extLst>
               <p:ext uri="{D42A27DB-BD31-4B8C-83A1-F6EECF244321}">
-                <p14:modId xmlns:p14="http://schemas.microsoft.com/office/powerpoint/2010/main" val="1029443845"/>
+                <p14:modId xmlns:p14="http://schemas.microsoft.com/office/powerpoint/2010/main" val="1792183451"/>
               </p:ext>
             </p:extLst>
           </p:nvPr>
@@ -5075,21 +5076,21 @@
                 <a:gridCol w="1820333">
                   <a:extLst>
                     <a:ext uri="{9D8B030D-6E8A-4147-A177-3AD203B41FA5}">
-                      <a16:colId xmlns:a16="http://schemas.microsoft.com/office/drawing/2014/main" val="1996026123"/>
+                      <a16:colId xmlns:a16="http://schemas.microsoft.com/office/drawing/2014/main" val="2652320985"/>
                     </a:ext>
                   </a:extLst>
                 </a:gridCol>
                 <a:gridCol w="1820333">
                   <a:extLst>
                     <a:ext uri="{9D8B030D-6E8A-4147-A177-3AD203B41FA5}">
-                      <a16:colId xmlns:a16="http://schemas.microsoft.com/office/drawing/2014/main" val="1062233843"/>
+                      <a16:colId xmlns:a16="http://schemas.microsoft.com/office/drawing/2014/main" val="1956142735"/>
                     </a:ext>
                   </a:extLst>
                 </a:gridCol>
                 <a:gridCol w="1820333">
                   <a:extLst>
                     <a:ext uri="{9D8B030D-6E8A-4147-A177-3AD203B41FA5}">
-                      <a16:colId xmlns:a16="http://schemas.microsoft.com/office/drawing/2014/main" val="192809521"/>
+                      <a16:colId xmlns:a16="http://schemas.microsoft.com/office/drawing/2014/main" val="524059772"/>
                     </a:ext>
                   </a:extLst>
                 </a:gridCol>
@@ -5136,7 +5137,7 @@
                 </a:tc>
                 <a:extLst>
                   <a:ext uri="{0D108BD9-81ED-4DB2-BD59-A6C34878D82A}">
-                    <a16:rowId xmlns:a16="http://schemas.microsoft.com/office/drawing/2014/main" val="3293346609"/>
+                    <a16:rowId xmlns:a16="http://schemas.microsoft.com/office/drawing/2014/main" val="325400333"/>
                   </a:ext>
                 </a:extLst>
               </a:tr>
@@ -5182,7 +5183,7 @@
                 </a:tc>
                 <a:extLst>
                   <a:ext uri="{0D108BD9-81ED-4DB2-BD59-A6C34878D82A}">
-                    <a16:rowId xmlns:a16="http://schemas.microsoft.com/office/drawing/2014/main" val="344133921"/>
+                    <a16:rowId xmlns:a16="http://schemas.microsoft.com/office/drawing/2014/main" val="104752680"/>
                   </a:ext>
                 </a:extLst>
               </a:tr>
@@ -5228,7 +5229,7 @@
                 </a:tc>
                 <a:extLst>
                   <a:ext uri="{0D108BD9-81ED-4DB2-BD59-A6C34878D82A}">
-                    <a16:rowId xmlns:a16="http://schemas.microsoft.com/office/drawing/2014/main" val="253924324"/>
+                    <a16:rowId xmlns:a16="http://schemas.microsoft.com/office/drawing/2014/main" val="1339314965"/>
                   </a:ext>
                 </a:extLst>
               </a:tr>
@@ -5274,7 +5275,7 @@
                 </a:tc>
                 <a:extLst>
                   <a:ext uri="{0D108BD9-81ED-4DB2-BD59-A6C34878D82A}">
-                    <a16:rowId xmlns:a16="http://schemas.microsoft.com/office/drawing/2014/main" val="3642123660"/>
+                    <a16:rowId xmlns:a16="http://schemas.microsoft.com/office/drawing/2014/main" val="3808215202"/>
                   </a:ext>
                 </a:extLst>
               </a:tr>
@@ -5285,7 +5286,7 @@
     </p:spTree>
     <p:extLst>
       <p:ext uri="{BB962C8B-B14F-4D97-AF65-F5344CB8AC3E}">
-        <p14:creationId xmlns:p14="http://schemas.microsoft.com/office/powerpoint/2010/main" val="1602495173"/>
+        <p14:creationId xmlns:p14="http://schemas.microsoft.com/office/powerpoint/2010/main" val="1329747592"/>
       </p:ext>
     </p:extLst>
   </p:cSld>
@@ -5317,7 +5318,7 @@
           <p:cNvPr id="2" name="Tabelle 1">
             <a:extLst>
               <a:ext uri="{FF2B5EF4-FFF2-40B4-BE49-F238E27FC236}">
-                <a16:creationId xmlns:a16="http://schemas.microsoft.com/office/drawing/2014/main" id="{6738C736-158E-04EB-5D3D-EA4F40708C5E}"/>
+                <a16:creationId xmlns:a16="http://schemas.microsoft.com/office/drawing/2014/main" id="{59DEC61F-7243-67D6-A5E8-8C255B8FA69E}"/>
               </a:ext>
             </a:extLst>
           </p:cNvPr>
@@ -5327,7 +5328,7 @@
           <p:nvPr>
             <p:extLst>
               <p:ext uri="{D42A27DB-BD31-4B8C-83A1-F6EECF244321}">
-                <p14:modId xmlns:p14="http://schemas.microsoft.com/office/powerpoint/2010/main" val="4222841045"/>
+                <p14:modId xmlns:p14="http://schemas.microsoft.com/office/powerpoint/2010/main" val="4037205339"/>
               </p:ext>
             </p:extLst>
           </p:nvPr>
@@ -5346,21 +5347,21 @@
                 <a:gridCol w="1820333">
                   <a:extLst>
                     <a:ext uri="{9D8B030D-6E8A-4147-A177-3AD203B41FA5}">
-                      <a16:colId xmlns:a16="http://schemas.microsoft.com/office/drawing/2014/main" val="4049660909"/>
+                      <a16:colId xmlns:a16="http://schemas.microsoft.com/office/drawing/2014/main" val="569477014"/>
                     </a:ext>
                   </a:extLst>
                 </a:gridCol>
                 <a:gridCol w="1820333">
                   <a:extLst>
                     <a:ext uri="{9D8B030D-6E8A-4147-A177-3AD203B41FA5}">
-                      <a16:colId xmlns:a16="http://schemas.microsoft.com/office/drawing/2014/main" val="2514629642"/>
+                      <a16:colId xmlns:a16="http://schemas.microsoft.com/office/drawing/2014/main" val="89078327"/>
                     </a:ext>
                   </a:extLst>
                 </a:gridCol>
                 <a:gridCol w="1820333">
                   <a:extLst>
                     <a:ext uri="{9D8B030D-6E8A-4147-A177-3AD203B41FA5}">
-                      <a16:colId xmlns:a16="http://schemas.microsoft.com/office/drawing/2014/main" val="3355632316"/>
+                      <a16:colId xmlns:a16="http://schemas.microsoft.com/office/drawing/2014/main" val="3233548793"/>
                     </a:ext>
                   </a:extLst>
                 </a:gridCol>
@@ -5407,7 +5408,7 @@
                 </a:tc>
                 <a:extLst>
                   <a:ext uri="{0D108BD9-81ED-4DB2-BD59-A6C34878D82A}">
-                    <a16:rowId xmlns:a16="http://schemas.microsoft.com/office/drawing/2014/main" val="652773342"/>
+                    <a16:rowId xmlns:a16="http://schemas.microsoft.com/office/drawing/2014/main" val="507869820"/>
                   </a:ext>
                 </a:extLst>
               </a:tr>
@@ -5453,7 +5454,7 @@
                 </a:tc>
                 <a:extLst>
                   <a:ext uri="{0D108BD9-81ED-4DB2-BD59-A6C34878D82A}">
-                    <a16:rowId xmlns:a16="http://schemas.microsoft.com/office/drawing/2014/main" val="3284559189"/>
+                    <a16:rowId xmlns:a16="http://schemas.microsoft.com/office/drawing/2014/main" val="695940184"/>
                   </a:ext>
                 </a:extLst>
               </a:tr>
@@ -5499,7 +5500,7 @@
                 </a:tc>
                 <a:extLst>
                   <a:ext uri="{0D108BD9-81ED-4DB2-BD59-A6C34878D82A}">
-                    <a16:rowId xmlns:a16="http://schemas.microsoft.com/office/drawing/2014/main" val="3928998721"/>
+                    <a16:rowId xmlns:a16="http://schemas.microsoft.com/office/drawing/2014/main" val="1953546862"/>
                   </a:ext>
                 </a:extLst>
               </a:tr>
@@ -5545,7 +5546,7 @@
                 </a:tc>
                 <a:extLst>
                   <a:ext uri="{0D108BD9-81ED-4DB2-BD59-A6C34878D82A}">
-                    <a16:rowId xmlns:a16="http://schemas.microsoft.com/office/drawing/2014/main" val="3176608725"/>
+                    <a16:rowId xmlns:a16="http://schemas.microsoft.com/office/drawing/2014/main" val="3588164971"/>
                   </a:ext>
                 </a:extLst>
               </a:tr>
@@ -5558,7 +5559,7 @@
           <p:cNvPr id="3" name="Tabelle 2">
             <a:extLst>
               <a:ext uri="{FF2B5EF4-FFF2-40B4-BE49-F238E27FC236}">
-                <a16:creationId xmlns:a16="http://schemas.microsoft.com/office/drawing/2014/main" id="{B2406724-501D-9B0E-190D-756ADF43994B}"/>
+                <a16:creationId xmlns:a16="http://schemas.microsoft.com/office/drawing/2014/main" id="{C5832BAC-22AD-7615-C59E-BB7E30D1ECD3}"/>
               </a:ext>
             </a:extLst>
           </p:cNvPr>
@@ -5568,7 +5569,7 @@
           <p:nvPr>
             <p:extLst>
               <p:ext uri="{D42A27DB-BD31-4B8C-83A1-F6EECF244321}">
-                <p14:modId xmlns:p14="http://schemas.microsoft.com/office/powerpoint/2010/main" val="1333781965"/>
+                <p14:modId xmlns:p14="http://schemas.microsoft.com/office/powerpoint/2010/main" val="1831453915"/>
               </p:ext>
             </p:extLst>
           </p:nvPr>
@@ -5587,21 +5588,21 @@
                 <a:gridCol w="1820333">
                   <a:extLst>
                     <a:ext uri="{9D8B030D-6E8A-4147-A177-3AD203B41FA5}">
-                      <a16:colId xmlns:a16="http://schemas.microsoft.com/office/drawing/2014/main" val="3970052804"/>
+                      <a16:colId xmlns:a16="http://schemas.microsoft.com/office/drawing/2014/main" val="2603086526"/>
                     </a:ext>
                   </a:extLst>
                 </a:gridCol>
                 <a:gridCol w="1820333">
                   <a:extLst>
                     <a:ext uri="{9D8B030D-6E8A-4147-A177-3AD203B41FA5}">
-                      <a16:colId xmlns:a16="http://schemas.microsoft.com/office/drawing/2014/main" val="296364081"/>
+                      <a16:colId xmlns:a16="http://schemas.microsoft.com/office/drawing/2014/main" val="3059702740"/>
                     </a:ext>
                   </a:extLst>
                 </a:gridCol>
                 <a:gridCol w="1820333">
                   <a:extLst>
                     <a:ext uri="{9D8B030D-6E8A-4147-A177-3AD203B41FA5}">
-                      <a16:colId xmlns:a16="http://schemas.microsoft.com/office/drawing/2014/main" val="1858893753"/>
+                      <a16:colId xmlns:a16="http://schemas.microsoft.com/office/drawing/2014/main" val="871410376"/>
                     </a:ext>
                   </a:extLst>
                 </a:gridCol>
@@ -5648,7 +5649,7 @@
                 </a:tc>
                 <a:extLst>
                   <a:ext uri="{0D108BD9-81ED-4DB2-BD59-A6C34878D82A}">
-                    <a16:rowId xmlns:a16="http://schemas.microsoft.com/office/drawing/2014/main" val="151484526"/>
+                    <a16:rowId xmlns:a16="http://schemas.microsoft.com/office/drawing/2014/main" val="1065770735"/>
                   </a:ext>
                 </a:extLst>
               </a:tr>
@@ -5694,7 +5695,7 @@
                 </a:tc>
                 <a:extLst>
                   <a:ext uri="{0D108BD9-81ED-4DB2-BD59-A6C34878D82A}">
-                    <a16:rowId xmlns:a16="http://schemas.microsoft.com/office/drawing/2014/main" val="2854309087"/>
+                    <a16:rowId xmlns:a16="http://schemas.microsoft.com/office/drawing/2014/main" val="2604860156"/>
                   </a:ext>
                 </a:extLst>
               </a:tr>
@@ -5740,7 +5741,7 @@
                 </a:tc>
                 <a:extLst>
                   <a:ext uri="{0D108BD9-81ED-4DB2-BD59-A6C34878D82A}">
-                    <a16:rowId xmlns:a16="http://schemas.microsoft.com/office/drawing/2014/main" val="909847937"/>
+                    <a16:rowId xmlns:a16="http://schemas.microsoft.com/office/drawing/2014/main" val="3009649613"/>
                   </a:ext>
                 </a:extLst>
               </a:tr>
@@ -5786,7 +5787,7 @@
                 </a:tc>
                 <a:extLst>
                   <a:ext uri="{0D108BD9-81ED-4DB2-BD59-A6C34878D82A}">
-                    <a16:rowId xmlns:a16="http://schemas.microsoft.com/office/drawing/2014/main" val="531349139"/>
+                    <a16:rowId xmlns:a16="http://schemas.microsoft.com/office/drawing/2014/main" val="997264338"/>
                   </a:ext>
                 </a:extLst>
               </a:tr>
@@ -5799,7 +5800,7 @@
           <p:cNvPr id="4" name="Tabelle 3">
             <a:extLst>
               <a:ext uri="{FF2B5EF4-FFF2-40B4-BE49-F238E27FC236}">
-                <a16:creationId xmlns:a16="http://schemas.microsoft.com/office/drawing/2014/main" id="{3E424BF3-AF7F-DD5D-1E46-C2529926ED60}"/>
+                <a16:creationId xmlns:a16="http://schemas.microsoft.com/office/drawing/2014/main" id="{B03E991C-7332-2059-C971-DF0464DFBBC7}"/>
               </a:ext>
             </a:extLst>
           </p:cNvPr>
@@ -5809,7 +5810,7 @@
           <p:nvPr>
             <p:extLst>
               <p:ext uri="{D42A27DB-BD31-4B8C-83A1-F6EECF244321}">
-                <p14:modId xmlns:p14="http://schemas.microsoft.com/office/powerpoint/2010/main" val="1656291509"/>
+                <p14:modId xmlns:p14="http://schemas.microsoft.com/office/powerpoint/2010/main" val="1445202474"/>
               </p:ext>
             </p:extLst>
           </p:nvPr>
@@ -5828,21 +5829,21 @@
                 <a:gridCol w="1820333">
                   <a:extLst>
                     <a:ext uri="{9D8B030D-6E8A-4147-A177-3AD203B41FA5}">
-                      <a16:colId xmlns:a16="http://schemas.microsoft.com/office/drawing/2014/main" val="4000404095"/>
+                      <a16:colId xmlns:a16="http://schemas.microsoft.com/office/drawing/2014/main" val="132610216"/>
                     </a:ext>
                   </a:extLst>
                 </a:gridCol>
                 <a:gridCol w="1820333">
                   <a:extLst>
                     <a:ext uri="{9D8B030D-6E8A-4147-A177-3AD203B41FA5}">
-                      <a16:colId xmlns:a16="http://schemas.microsoft.com/office/drawing/2014/main" val="1868611453"/>
+                      <a16:colId xmlns:a16="http://schemas.microsoft.com/office/drawing/2014/main" val="670619268"/>
                     </a:ext>
                   </a:extLst>
                 </a:gridCol>
                 <a:gridCol w="1820333">
                   <a:extLst>
                     <a:ext uri="{9D8B030D-6E8A-4147-A177-3AD203B41FA5}">
-                      <a16:colId xmlns:a16="http://schemas.microsoft.com/office/drawing/2014/main" val="2313620974"/>
+                      <a16:colId xmlns:a16="http://schemas.microsoft.com/office/drawing/2014/main" val="2934582166"/>
                     </a:ext>
                   </a:extLst>
                 </a:gridCol>
@@ -5889,7 +5890,7 @@
                 </a:tc>
                 <a:extLst>
                   <a:ext uri="{0D108BD9-81ED-4DB2-BD59-A6C34878D82A}">
-                    <a16:rowId xmlns:a16="http://schemas.microsoft.com/office/drawing/2014/main" val="4177333001"/>
+                    <a16:rowId xmlns:a16="http://schemas.microsoft.com/office/drawing/2014/main" val="1716427629"/>
                   </a:ext>
                 </a:extLst>
               </a:tr>
@@ -5935,7 +5936,7 @@
                 </a:tc>
                 <a:extLst>
                   <a:ext uri="{0D108BD9-81ED-4DB2-BD59-A6C34878D82A}">
-                    <a16:rowId xmlns:a16="http://schemas.microsoft.com/office/drawing/2014/main" val="1944914530"/>
+                    <a16:rowId xmlns:a16="http://schemas.microsoft.com/office/drawing/2014/main" val="2845281736"/>
                   </a:ext>
                 </a:extLst>
               </a:tr>
@@ -5981,7 +5982,7 @@
                 </a:tc>
                 <a:extLst>
                   <a:ext uri="{0D108BD9-81ED-4DB2-BD59-A6C34878D82A}">
-                    <a16:rowId xmlns:a16="http://schemas.microsoft.com/office/drawing/2014/main" val="1300486984"/>
+                    <a16:rowId xmlns:a16="http://schemas.microsoft.com/office/drawing/2014/main" val="125291515"/>
                   </a:ext>
                 </a:extLst>
               </a:tr>
@@ -6027,7 +6028,7 @@
                 </a:tc>
                 <a:extLst>
                   <a:ext uri="{0D108BD9-81ED-4DB2-BD59-A6C34878D82A}">
-                    <a16:rowId xmlns:a16="http://schemas.microsoft.com/office/drawing/2014/main" val="1133809440"/>
+                    <a16:rowId xmlns:a16="http://schemas.microsoft.com/office/drawing/2014/main" val="2364468871"/>
                   </a:ext>
                 </a:extLst>
               </a:tr>
@@ -6040,7 +6041,7 @@
           <p:cNvPr id="5" name="Tabelle 4">
             <a:extLst>
               <a:ext uri="{FF2B5EF4-FFF2-40B4-BE49-F238E27FC236}">
-                <a16:creationId xmlns:a16="http://schemas.microsoft.com/office/drawing/2014/main" id="{1C6B765D-2E18-4623-F5A6-A9362574568D}"/>
+                <a16:creationId xmlns:a16="http://schemas.microsoft.com/office/drawing/2014/main" id="{6875D210-437B-AEAD-49E3-EBB1C560B12A}"/>
               </a:ext>
             </a:extLst>
           </p:cNvPr>
@@ -6050,7 +6051,7 @@
           <p:nvPr>
             <p:extLst>
               <p:ext uri="{D42A27DB-BD31-4B8C-83A1-F6EECF244321}">
-                <p14:modId xmlns:p14="http://schemas.microsoft.com/office/powerpoint/2010/main" val="655440763"/>
+                <p14:modId xmlns:p14="http://schemas.microsoft.com/office/powerpoint/2010/main" val="3462233488"/>
               </p:ext>
             </p:extLst>
           </p:nvPr>
@@ -6069,21 +6070,21 @@
                 <a:gridCol w="1820333">
                   <a:extLst>
                     <a:ext uri="{9D8B030D-6E8A-4147-A177-3AD203B41FA5}">
-                      <a16:colId xmlns:a16="http://schemas.microsoft.com/office/drawing/2014/main" val="3387547613"/>
+                      <a16:colId xmlns:a16="http://schemas.microsoft.com/office/drawing/2014/main" val="4253363555"/>
                     </a:ext>
                   </a:extLst>
                 </a:gridCol>
                 <a:gridCol w="1820333">
                   <a:extLst>
                     <a:ext uri="{9D8B030D-6E8A-4147-A177-3AD203B41FA5}">
-                      <a16:colId xmlns:a16="http://schemas.microsoft.com/office/drawing/2014/main" val="1357135471"/>
+                      <a16:colId xmlns:a16="http://schemas.microsoft.com/office/drawing/2014/main" val="2213278313"/>
                     </a:ext>
                   </a:extLst>
                 </a:gridCol>
                 <a:gridCol w="1820333">
                   <a:extLst>
                     <a:ext uri="{9D8B030D-6E8A-4147-A177-3AD203B41FA5}">
-                      <a16:colId xmlns:a16="http://schemas.microsoft.com/office/drawing/2014/main" val="18991237"/>
+                      <a16:colId xmlns:a16="http://schemas.microsoft.com/office/drawing/2014/main" val="1209007331"/>
                     </a:ext>
                   </a:extLst>
                 </a:gridCol>
@@ -6130,7 +6131,7 @@
                 </a:tc>
                 <a:extLst>
                   <a:ext uri="{0D108BD9-81ED-4DB2-BD59-A6C34878D82A}">
-                    <a16:rowId xmlns:a16="http://schemas.microsoft.com/office/drawing/2014/main" val="2832716223"/>
+                    <a16:rowId xmlns:a16="http://schemas.microsoft.com/office/drawing/2014/main" val="2526474401"/>
                   </a:ext>
                 </a:extLst>
               </a:tr>
@@ -6176,7 +6177,7 @@
                 </a:tc>
                 <a:extLst>
                   <a:ext uri="{0D108BD9-81ED-4DB2-BD59-A6C34878D82A}">
-                    <a16:rowId xmlns:a16="http://schemas.microsoft.com/office/drawing/2014/main" val="4102506070"/>
+                    <a16:rowId xmlns:a16="http://schemas.microsoft.com/office/drawing/2014/main" val="1561681215"/>
                   </a:ext>
                 </a:extLst>
               </a:tr>
@@ -6222,7 +6223,7 @@
                 </a:tc>
                 <a:extLst>
                   <a:ext uri="{0D108BD9-81ED-4DB2-BD59-A6C34878D82A}">
-                    <a16:rowId xmlns:a16="http://schemas.microsoft.com/office/drawing/2014/main" val="124233125"/>
+                    <a16:rowId xmlns:a16="http://schemas.microsoft.com/office/drawing/2014/main" val="1560388015"/>
                   </a:ext>
                 </a:extLst>
               </a:tr>
@@ -6268,7 +6269,7 @@
                 </a:tc>
                 <a:extLst>
                   <a:ext uri="{0D108BD9-81ED-4DB2-BD59-A6C34878D82A}">
-                    <a16:rowId xmlns:a16="http://schemas.microsoft.com/office/drawing/2014/main" val="897325210"/>
+                    <a16:rowId xmlns:a16="http://schemas.microsoft.com/office/drawing/2014/main" val="125812854"/>
                   </a:ext>
                 </a:extLst>
               </a:tr>
@@ -6279,7 +6280,7 @@
     </p:spTree>
     <p:extLst>
       <p:ext uri="{BB962C8B-B14F-4D97-AF65-F5344CB8AC3E}">
-        <p14:creationId xmlns:p14="http://schemas.microsoft.com/office/powerpoint/2010/main" val="2437162031"/>
+        <p14:creationId xmlns:p14="http://schemas.microsoft.com/office/powerpoint/2010/main" val="3231636498"/>
       </p:ext>
     </p:extLst>
   </p:cSld>
@@ -6311,7 +6312,7 @@
           <p:cNvPr id="2" name="Tabelle 1">
             <a:extLst>
               <a:ext uri="{FF2B5EF4-FFF2-40B4-BE49-F238E27FC236}">
-                <a16:creationId xmlns:a16="http://schemas.microsoft.com/office/drawing/2014/main" id="{C7CA6566-92BE-F875-5D0E-396B1F29C846}"/>
+                <a16:creationId xmlns:a16="http://schemas.microsoft.com/office/drawing/2014/main" id="{6A7D49F7-5130-6102-8C2E-C4BD439EC6B2}"/>
               </a:ext>
             </a:extLst>
           </p:cNvPr>
@@ -6321,7 +6322,7 @@
           <p:nvPr>
             <p:extLst>
               <p:ext uri="{D42A27DB-BD31-4B8C-83A1-F6EECF244321}">
-                <p14:modId xmlns:p14="http://schemas.microsoft.com/office/powerpoint/2010/main" val="1256716885"/>
+                <p14:modId xmlns:p14="http://schemas.microsoft.com/office/powerpoint/2010/main" val="3401923701"/>
               </p:ext>
             </p:extLst>
           </p:nvPr>
@@ -6340,28 +6341,28 @@
                 <a:gridCol w="1651000">
                   <a:extLst>
                     <a:ext uri="{9D8B030D-6E8A-4147-A177-3AD203B41FA5}">
-                      <a16:colId xmlns:a16="http://schemas.microsoft.com/office/drawing/2014/main" val="3481877159"/>
+                      <a16:colId xmlns:a16="http://schemas.microsoft.com/office/drawing/2014/main" val="3465439331"/>
                     </a:ext>
                   </a:extLst>
                 </a:gridCol>
                 <a:gridCol w="1651000">
                   <a:extLst>
                     <a:ext uri="{9D8B030D-6E8A-4147-A177-3AD203B41FA5}">
-                      <a16:colId xmlns:a16="http://schemas.microsoft.com/office/drawing/2014/main" val="2567360379"/>
+                      <a16:colId xmlns:a16="http://schemas.microsoft.com/office/drawing/2014/main" val="2304711039"/>
                     </a:ext>
                   </a:extLst>
                 </a:gridCol>
                 <a:gridCol w="1651000">
                   <a:extLst>
                     <a:ext uri="{9D8B030D-6E8A-4147-A177-3AD203B41FA5}">
-                      <a16:colId xmlns:a16="http://schemas.microsoft.com/office/drawing/2014/main" val="2129775098"/>
+                      <a16:colId xmlns:a16="http://schemas.microsoft.com/office/drawing/2014/main" val="957413065"/>
                     </a:ext>
                   </a:extLst>
                 </a:gridCol>
                 <a:gridCol w="1651000">
                   <a:extLst>
                     <a:ext uri="{9D8B030D-6E8A-4147-A177-3AD203B41FA5}">
-                      <a16:colId xmlns:a16="http://schemas.microsoft.com/office/drawing/2014/main" val="2219468282"/>
+                      <a16:colId xmlns:a16="http://schemas.microsoft.com/office/drawing/2014/main" val="4259530740"/>
                     </a:ext>
                   </a:extLst>
                 </a:gridCol>
@@ -6434,7 +6435,7 @@
                 </a:tc>
                 <a:extLst>
                   <a:ext uri="{0D108BD9-81ED-4DB2-BD59-A6C34878D82A}">
-                    <a16:rowId xmlns:a16="http://schemas.microsoft.com/office/drawing/2014/main" val="4224178445"/>
+                    <a16:rowId xmlns:a16="http://schemas.microsoft.com/office/drawing/2014/main" val="325036430"/>
                   </a:ext>
                 </a:extLst>
               </a:tr>
@@ -6499,7 +6500,7 @@
                 </a:tc>
                 <a:extLst>
                   <a:ext uri="{0D108BD9-81ED-4DB2-BD59-A6C34878D82A}">
-                    <a16:rowId xmlns:a16="http://schemas.microsoft.com/office/drawing/2014/main" val="730048900"/>
+                    <a16:rowId xmlns:a16="http://schemas.microsoft.com/office/drawing/2014/main" val="1984264484"/>
                   </a:ext>
                 </a:extLst>
               </a:tr>
@@ -6570,7 +6571,7 @@
                 </a:tc>
                 <a:extLst>
                   <a:ext uri="{0D108BD9-81ED-4DB2-BD59-A6C34878D82A}">
-                    <a16:rowId xmlns:a16="http://schemas.microsoft.com/office/drawing/2014/main" val="1045675061"/>
+                    <a16:rowId xmlns:a16="http://schemas.microsoft.com/office/drawing/2014/main" val="3766560713"/>
                   </a:ext>
                 </a:extLst>
               </a:tr>
@@ -6641,7 +6642,7 @@
                 </a:tc>
                 <a:extLst>
                   <a:ext uri="{0D108BD9-81ED-4DB2-BD59-A6C34878D82A}">
-                    <a16:rowId xmlns:a16="http://schemas.microsoft.com/office/drawing/2014/main" val="1484422067"/>
+                    <a16:rowId xmlns:a16="http://schemas.microsoft.com/office/drawing/2014/main" val="2274978431"/>
                   </a:ext>
                 </a:extLst>
               </a:tr>
@@ -6691,7 +6692,7 @@
                 </a:tc>
                 <a:extLst>
                   <a:ext uri="{0D108BD9-81ED-4DB2-BD59-A6C34878D82A}">
-                    <a16:rowId xmlns:a16="http://schemas.microsoft.com/office/drawing/2014/main" val="3935525487"/>
+                    <a16:rowId xmlns:a16="http://schemas.microsoft.com/office/drawing/2014/main" val="3160684437"/>
                   </a:ext>
                 </a:extLst>
               </a:tr>
@@ -6704,7 +6705,7 @@
           <p:cNvPr id="3" name="Tabelle 2">
             <a:extLst>
               <a:ext uri="{FF2B5EF4-FFF2-40B4-BE49-F238E27FC236}">
-                <a16:creationId xmlns:a16="http://schemas.microsoft.com/office/drawing/2014/main" id="{2DF8BB84-3544-95D4-1B25-B8FBBF1AAABC}"/>
+                <a16:creationId xmlns:a16="http://schemas.microsoft.com/office/drawing/2014/main" id="{C5201B0C-DAC8-201C-E368-F2532EF5F025}"/>
               </a:ext>
             </a:extLst>
           </p:cNvPr>
@@ -6714,7 +6715,7 @@
           <p:nvPr>
             <p:extLst>
               <p:ext uri="{D42A27DB-BD31-4B8C-83A1-F6EECF244321}">
-                <p14:modId xmlns:p14="http://schemas.microsoft.com/office/powerpoint/2010/main" val="3073214216"/>
+                <p14:modId xmlns:p14="http://schemas.microsoft.com/office/powerpoint/2010/main" val="3383053450"/>
               </p:ext>
             </p:extLst>
           </p:nvPr>
@@ -6733,21 +6734,21 @@
                 <a:gridCol w="1481667">
                   <a:extLst>
                     <a:ext uri="{9D8B030D-6E8A-4147-A177-3AD203B41FA5}">
-                      <a16:colId xmlns:a16="http://schemas.microsoft.com/office/drawing/2014/main" val="3853644869"/>
+                      <a16:colId xmlns:a16="http://schemas.microsoft.com/office/drawing/2014/main" val="1555858034"/>
                     </a:ext>
                   </a:extLst>
                 </a:gridCol>
                 <a:gridCol w="1481667">
                   <a:extLst>
                     <a:ext uri="{9D8B030D-6E8A-4147-A177-3AD203B41FA5}">
-                      <a16:colId xmlns:a16="http://schemas.microsoft.com/office/drawing/2014/main" val="3076364414"/>
+                      <a16:colId xmlns:a16="http://schemas.microsoft.com/office/drawing/2014/main" val="3588977550"/>
                     </a:ext>
                   </a:extLst>
                 </a:gridCol>
                 <a:gridCol w="1481667">
                   <a:extLst>
                     <a:ext uri="{9D8B030D-6E8A-4147-A177-3AD203B41FA5}">
-                      <a16:colId xmlns:a16="http://schemas.microsoft.com/office/drawing/2014/main" val="375861039"/>
+                      <a16:colId xmlns:a16="http://schemas.microsoft.com/office/drawing/2014/main" val="3653280104"/>
                     </a:ext>
                   </a:extLst>
                 </a:gridCol>
@@ -6794,7 +6795,7 @@
                 </a:tc>
                 <a:extLst>
                   <a:ext uri="{0D108BD9-81ED-4DB2-BD59-A6C34878D82A}">
-                    <a16:rowId xmlns:a16="http://schemas.microsoft.com/office/drawing/2014/main" val="2402347014"/>
+                    <a16:rowId xmlns:a16="http://schemas.microsoft.com/office/drawing/2014/main" val="3797209727"/>
                   </a:ext>
                 </a:extLst>
               </a:tr>
@@ -6844,7 +6845,7 @@
                 </a:tc>
                 <a:extLst>
                   <a:ext uri="{0D108BD9-81ED-4DB2-BD59-A6C34878D82A}">
-                    <a16:rowId xmlns:a16="http://schemas.microsoft.com/office/drawing/2014/main" val="1816293090"/>
+                    <a16:rowId xmlns:a16="http://schemas.microsoft.com/office/drawing/2014/main" val="1925634605"/>
                   </a:ext>
                 </a:extLst>
               </a:tr>
@@ -6891,7 +6892,7 @@
                 </a:tc>
                 <a:extLst>
                   <a:ext uri="{0D108BD9-81ED-4DB2-BD59-A6C34878D82A}">
-                    <a16:rowId xmlns:a16="http://schemas.microsoft.com/office/drawing/2014/main" val="1677625760"/>
+                    <a16:rowId xmlns:a16="http://schemas.microsoft.com/office/drawing/2014/main" val="1263744333"/>
                   </a:ext>
                 </a:extLst>
               </a:tr>
@@ -6902,7 +6903,609 @@
     </p:spTree>
     <p:extLst>
       <p:ext uri="{BB962C8B-B14F-4D97-AF65-F5344CB8AC3E}">
-        <p14:creationId xmlns:p14="http://schemas.microsoft.com/office/powerpoint/2010/main" val="3713327568"/>
+        <p14:creationId xmlns:p14="http://schemas.microsoft.com/office/powerpoint/2010/main" val="2900181522"/>
+      </p:ext>
+    </p:extLst>
+  </p:cSld>
+  <p:clrMapOvr>
+    <a:masterClrMapping/>
+  </p:clrMapOvr>
+</p:sld>
+</file>
+
+<file path=ppt/slides/slide5.xml><?xml version="1.0" encoding="utf-8"?>
+<p:sld xmlns:a="http://schemas.openxmlformats.org/drawingml/2006/main" xmlns:r="http://schemas.openxmlformats.org/officeDocument/2006/relationships" xmlns:p="http://schemas.openxmlformats.org/presentationml/2006/main">
+  <p:cSld>
+    <p:spTree>
+      <p:nvGrpSpPr>
+        <p:cNvPr id="1" name=""/>
+        <p:cNvGrpSpPr/>
+        <p:nvPr/>
+      </p:nvGrpSpPr>
+      <p:grpSpPr>
+        <a:xfrm>
+          <a:off x="0" y="0"/>
+          <a:ext cx="0" cy="0"/>
+          <a:chOff x="0" y="0"/>
+          <a:chExt cx="0" cy="0"/>
+        </a:xfrm>
+      </p:grpSpPr>
+      <p:graphicFrame>
+        <p:nvGraphicFramePr>
+          <p:cNvPr id="2" name="Tabelle 1">
+            <a:extLst>
+              <a:ext uri="{FF2B5EF4-FFF2-40B4-BE49-F238E27FC236}">
+                <a16:creationId xmlns:a16="http://schemas.microsoft.com/office/drawing/2014/main" id="{E94E3B1D-B6D2-3FBA-B823-420B0295FE90}"/>
+              </a:ext>
+            </a:extLst>
+          </p:cNvPr>
+          <p:cNvGraphicFramePr>
+            <a:graphicFrameLocks noGrp="1"/>
+          </p:cNvGraphicFramePr>
+          <p:nvPr>
+            <p:extLst>
+              <p:ext uri="{D42A27DB-BD31-4B8C-83A1-F6EECF244321}">
+                <p14:modId xmlns:p14="http://schemas.microsoft.com/office/powerpoint/2010/main" val="737570188"/>
+              </p:ext>
+            </p:extLst>
+          </p:nvPr>
+        </p:nvGraphicFramePr>
+        <p:xfrm>
+          <a:off x="381000" y="381000"/>
+          <a:ext cx="5334000" cy="1905000"/>
+        </p:xfrm>
+        <a:graphic>
+          <a:graphicData uri="http://schemas.openxmlformats.org/drawingml/2006/table">
+            <a:tbl>
+              <a:tblPr rtl="1" firstRow="1" bandRow="1">
+                <a:tableStyleId>{5C22544A-7EE6-4342-B048-85BDC9FD1C3A}</a:tableStyleId>
+              </a:tblPr>
+              <a:tblGrid>
+                <a:gridCol w="1778000">
+                  <a:extLst>
+                    <a:ext uri="{9D8B030D-6E8A-4147-A177-3AD203B41FA5}">
+                      <a16:colId xmlns:a16="http://schemas.microsoft.com/office/drawing/2014/main" val="936019658"/>
+                    </a:ext>
+                  </a:extLst>
+                </a:gridCol>
+                <a:gridCol w="1778000">
+                  <a:extLst>
+                    <a:ext uri="{9D8B030D-6E8A-4147-A177-3AD203B41FA5}">
+                      <a16:colId xmlns:a16="http://schemas.microsoft.com/office/drawing/2014/main" val="1779147968"/>
+                    </a:ext>
+                  </a:extLst>
+                </a:gridCol>
+                <a:gridCol w="1778000">
+                  <a:extLst>
+                    <a:ext uri="{9D8B030D-6E8A-4147-A177-3AD203B41FA5}">
+                      <a16:colId xmlns:a16="http://schemas.microsoft.com/office/drawing/2014/main" val="1348897353"/>
+                    </a:ext>
+                  </a:extLst>
+                </a:gridCol>
+              </a:tblGrid>
+              <a:tr h="635000">
+                <a:tc>
+                  <a:txBody>
+                    <a:bodyPr/>
+                    <a:lstStyle/>
+                    <a:p>
+                      <a:r>
+                        <a:rPr lang="de-DE"/>
+                        <a:t>R1 C1</a:t>
+                      </a:r>
+                    </a:p>
+                  </a:txBody>
+                  <a:tcPr>
+                    <a:lnB w="50800" cmpd="sng">
+                      <a:solidFill>
+                        <a:srgbClr val="DC0000"/>
+                      </a:solidFill>
+                    </a:lnB>
+                  </a:tcPr>
+                </a:tc>
+                <a:tc>
+                  <a:txBody>
+                    <a:bodyPr/>
+                    <a:lstStyle/>
+                    <a:p>
+                      <a:r>
+                        <a:rPr lang="de-DE"/>
+                        <a:t>R1 C2</a:t>
+                      </a:r>
+                    </a:p>
+                  </a:txBody>
+                  <a:tcPr/>
+                </a:tc>
+                <a:tc>
+                  <a:txBody>
+                    <a:bodyPr/>
+                    <a:lstStyle/>
+                    <a:p>
+                      <a:r>
+                        <a:rPr lang="de-DE"/>
+                        <a:t>R1 C3</a:t>
+                      </a:r>
+                    </a:p>
+                  </a:txBody>
+                  <a:tcPr/>
+                </a:tc>
+                <a:extLst>
+                  <a:ext uri="{0D108BD9-81ED-4DB2-BD59-A6C34878D82A}">
+                    <a16:rowId xmlns:a16="http://schemas.microsoft.com/office/drawing/2014/main" val="3015498856"/>
+                  </a:ext>
+                </a:extLst>
+              </a:tr>
+              <a:tr h="635000">
+                <a:tc>
+                  <a:txBody>
+                    <a:bodyPr/>
+                    <a:lstStyle/>
+                    <a:p>
+                      <a:r>
+                        <a:rPr lang="de-DE"/>
+                        <a:t>R2 C1</a:t>
+                      </a:r>
+                    </a:p>
+                  </a:txBody>
+                  <a:tcPr>
+                    <a:lnL w="50800" cmpd="sng">
+                      <a:solidFill>
+                        <a:srgbClr val="00C800"/>
+                      </a:solidFill>
+                    </a:lnL>
+                    <a:lnT w="50800" cmpd="sng">
+                      <a:solidFill>
+                        <a:srgbClr val="DC0000"/>
+                      </a:solidFill>
+                    </a:lnT>
+                  </a:tcPr>
+                </a:tc>
+                <a:tc>
+                  <a:txBody>
+                    <a:bodyPr/>
+                    <a:lstStyle/>
+                    <a:p>
+                      <a:r>
+                        <a:rPr lang="de-DE"/>
+                        <a:t>R2 C2</a:t>
+                      </a:r>
+                    </a:p>
+                  </a:txBody>
+                  <a:tcPr/>
+                </a:tc>
+                <a:tc>
+                  <a:txBody>
+                    <a:bodyPr/>
+                    <a:lstStyle/>
+                    <a:p>
+                      <a:r>
+                        <a:rPr lang="de-DE"/>
+                        <a:t>R2 C3</a:t>
+                      </a:r>
+                    </a:p>
+                  </a:txBody>
+                  <a:tcPr/>
+                </a:tc>
+                <a:extLst>
+                  <a:ext uri="{0D108BD9-81ED-4DB2-BD59-A6C34878D82A}">
+                    <a16:rowId xmlns:a16="http://schemas.microsoft.com/office/drawing/2014/main" val="3784315243"/>
+                  </a:ext>
+                </a:extLst>
+              </a:tr>
+              <a:tr h="635000">
+                <a:tc>
+                  <a:txBody>
+                    <a:bodyPr/>
+                    <a:lstStyle/>
+                    <a:p>
+                      <a:r>
+                        <a:rPr lang="de-DE"/>
+                        <a:t>R3 C1</a:t>
+                      </a:r>
+                    </a:p>
+                  </a:txBody>
+                  <a:tcPr/>
+                </a:tc>
+                <a:tc>
+                  <a:txBody>
+                    <a:bodyPr/>
+                    <a:lstStyle/>
+                    <a:p>
+                      <a:r>
+                        <a:rPr lang="de-DE"/>
+                        <a:t>R3 C2</a:t>
+                      </a:r>
+                    </a:p>
+                  </a:txBody>
+                  <a:tcPr/>
+                </a:tc>
+                <a:tc>
+                  <a:txBody>
+                    <a:bodyPr/>
+                    <a:lstStyle/>
+                    <a:p>
+                      <a:r>
+                        <a:rPr lang="de-DE"/>
+                        <a:t>R3 C3</a:t>
+                      </a:r>
+                    </a:p>
+                  </a:txBody>
+                  <a:tcPr/>
+                </a:tc>
+                <a:extLst>
+                  <a:ext uri="{0D108BD9-81ED-4DB2-BD59-A6C34878D82A}">
+                    <a16:rowId xmlns:a16="http://schemas.microsoft.com/office/drawing/2014/main" val="3829707015"/>
+                  </a:ext>
+                </a:extLst>
+              </a:tr>
+            </a:tbl>
+          </a:graphicData>
+        </a:graphic>
+      </p:graphicFrame>
+      <p:graphicFrame>
+        <p:nvGraphicFramePr>
+          <p:cNvPr id="3" name="Tabelle 2">
+            <a:extLst>
+              <a:ext uri="{FF2B5EF4-FFF2-40B4-BE49-F238E27FC236}">
+                <a16:creationId xmlns:a16="http://schemas.microsoft.com/office/drawing/2014/main" id="{EF0D09EA-1681-D393-23D3-3E876D59F05E}"/>
+              </a:ext>
+            </a:extLst>
+          </p:cNvPr>
+          <p:cNvGraphicFramePr>
+            <a:graphicFrameLocks noGrp="1"/>
+          </p:cNvGraphicFramePr>
+          <p:nvPr>
+            <p:extLst>
+              <p:ext uri="{D42A27DB-BD31-4B8C-83A1-F6EECF244321}">
+                <p14:modId xmlns:p14="http://schemas.microsoft.com/office/powerpoint/2010/main" val="3179972939"/>
+              </p:ext>
+            </p:extLst>
+          </p:nvPr>
+        </p:nvGraphicFramePr>
+        <p:xfrm>
+          <a:off x="6350000" y="381000"/>
+          <a:ext cx="5334000" cy="1905000"/>
+        </p:xfrm>
+        <a:graphic>
+          <a:graphicData uri="http://schemas.openxmlformats.org/drawingml/2006/table">
+            <a:tbl>
+              <a:tblPr firstRow="1" bandRow="1">
+                <a:tableStyleId>{5C22544A-7EE6-4342-B048-85BDC9FD1C3A}</a:tableStyleId>
+              </a:tblPr>
+              <a:tblGrid>
+                <a:gridCol w="1778000">
+                  <a:extLst>
+                    <a:ext uri="{9D8B030D-6E8A-4147-A177-3AD203B41FA5}">
+                      <a16:colId xmlns:a16="http://schemas.microsoft.com/office/drawing/2014/main" val="3614099313"/>
+                    </a:ext>
+                  </a:extLst>
+                </a:gridCol>
+                <a:gridCol w="1778000">
+                  <a:extLst>
+                    <a:ext uri="{9D8B030D-6E8A-4147-A177-3AD203B41FA5}">
+                      <a16:colId xmlns:a16="http://schemas.microsoft.com/office/drawing/2014/main" val="2494179273"/>
+                    </a:ext>
+                  </a:extLst>
+                </a:gridCol>
+                <a:gridCol w="1778000">
+                  <a:extLst>
+                    <a:ext uri="{9D8B030D-6E8A-4147-A177-3AD203B41FA5}">
+                      <a16:colId xmlns:a16="http://schemas.microsoft.com/office/drawing/2014/main" val="870534701"/>
+                    </a:ext>
+                  </a:extLst>
+                </a:gridCol>
+              </a:tblGrid>
+              <a:tr h="635000">
+                <a:tc>
+                  <a:txBody>
+                    <a:bodyPr/>
+                    <a:lstStyle/>
+                    <a:p>
+                      <a:r>
+                        <a:rPr lang="de-DE"/>
+                        <a:t>R1 C1</a:t>
+                      </a:r>
+                    </a:p>
+                  </a:txBody>
+                  <a:tcPr>
+                    <a:lnB w="50800" cmpd="sng">
+                      <a:solidFill>
+                        <a:srgbClr val="DC0000"/>
+                      </a:solidFill>
+                    </a:lnB>
+                  </a:tcPr>
+                </a:tc>
+                <a:tc>
+                  <a:txBody>
+                    <a:bodyPr/>
+                    <a:lstStyle/>
+                    <a:p>
+                      <a:r>
+                        <a:rPr lang="de-DE"/>
+                        <a:t>R1 C2</a:t>
+                      </a:r>
+                    </a:p>
+                  </a:txBody>
+                  <a:tcPr/>
+                </a:tc>
+                <a:tc>
+                  <a:txBody>
+                    <a:bodyPr/>
+                    <a:lstStyle/>
+                    <a:p>
+                      <a:r>
+                        <a:rPr lang="de-DE"/>
+                        <a:t>R1 C3</a:t>
+                      </a:r>
+                    </a:p>
+                  </a:txBody>
+                  <a:tcPr/>
+                </a:tc>
+                <a:extLst>
+                  <a:ext uri="{0D108BD9-81ED-4DB2-BD59-A6C34878D82A}">
+                    <a16:rowId xmlns:a16="http://schemas.microsoft.com/office/drawing/2014/main" val="529670748"/>
+                  </a:ext>
+                </a:extLst>
+              </a:tr>
+              <a:tr h="635000">
+                <a:tc>
+                  <a:txBody>
+                    <a:bodyPr/>
+                    <a:lstStyle/>
+                    <a:p>
+                      <a:r>
+                        <a:rPr lang="de-DE"/>
+                        <a:t>R2 C1</a:t>
+                      </a:r>
+                    </a:p>
+                  </a:txBody>
+                  <a:tcPr>
+                    <a:lnL w="50800" cmpd="sng">
+                      <a:solidFill>
+                        <a:srgbClr val="00C800"/>
+                      </a:solidFill>
+                    </a:lnL>
+                    <a:lnT w="50800" cmpd="sng">
+                      <a:solidFill>
+                        <a:srgbClr val="DC0000"/>
+                      </a:solidFill>
+                    </a:lnT>
+                  </a:tcPr>
+                </a:tc>
+                <a:tc>
+                  <a:txBody>
+                    <a:bodyPr/>
+                    <a:lstStyle/>
+                    <a:p>
+                      <a:r>
+                        <a:rPr lang="de-DE"/>
+                        <a:t>R2 C2</a:t>
+                      </a:r>
+                    </a:p>
+                  </a:txBody>
+                  <a:tcPr/>
+                </a:tc>
+                <a:tc>
+                  <a:txBody>
+                    <a:bodyPr/>
+                    <a:lstStyle/>
+                    <a:p>
+                      <a:r>
+                        <a:rPr lang="de-DE"/>
+                        <a:t>R2 C3</a:t>
+                      </a:r>
+                    </a:p>
+                  </a:txBody>
+                  <a:tcPr/>
+                </a:tc>
+                <a:extLst>
+                  <a:ext uri="{0D108BD9-81ED-4DB2-BD59-A6C34878D82A}">
+                    <a16:rowId xmlns:a16="http://schemas.microsoft.com/office/drawing/2014/main" val="1501241925"/>
+                  </a:ext>
+                </a:extLst>
+              </a:tr>
+              <a:tr h="635000">
+                <a:tc>
+                  <a:txBody>
+                    <a:bodyPr/>
+                    <a:lstStyle/>
+                    <a:p>
+                      <a:r>
+                        <a:rPr lang="de-DE"/>
+                        <a:t>R3 C1</a:t>
+                      </a:r>
+                    </a:p>
+                  </a:txBody>
+                  <a:tcPr/>
+                </a:tc>
+                <a:tc>
+                  <a:txBody>
+                    <a:bodyPr/>
+                    <a:lstStyle/>
+                    <a:p>
+                      <a:r>
+                        <a:rPr lang="de-DE"/>
+                        <a:t>R3 C2</a:t>
+                      </a:r>
+                    </a:p>
+                  </a:txBody>
+                  <a:tcPr/>
+                </a:tc>
+                <a:tc>
+                  <a:txBody>
+                    <a:bodyPr/>
+                    <a:lstStyle/>
+                    <a:p>
+                      <a:r>
+                        <a:rPr lang="de-DE"/>
+                        <a:t>R3 C3</a:t>
+                      </a:r>
+                    </a:p>
+                  </a:txBody>
+                  <a:tcPr/>
+                </a:tc>
+                <a:extLst>
+                  <a:ext uri="{0D108BD9-81ED-4DB2-BD59-A6C34878D82A}">
+                    <a16:rowId xmlns:a16="http://schemas.microsoft.com/office/drawing/2014/main" val="1563013777"/>
+                  </a:ext>
+                </a:extLst>
+              </a:tr>
+            </a:tbl>
+          </a:graphicData>
+        </a:graphic>
+      </p:graphicFrame>
+      <p:graphicFrame>
+        <p:nvGraphicFramePr>
+          <p:cNvPr id="4" name="anchorCtr-cells">
+            <a:extLst>
+              <a:ext uri="{FF2B5EF4-FFF2-40B4-BE49-F238E27FC236}">
+                <a16:creationId xmlns:a16="http://schemas.microsoft.com/office/drawing/2014/main" id="{2E1B64E6-D590-1041-84F2-9F3D693EC0A1}"/>
+              </a:ext>
+            </a:extLst>
+          </p:cNvPr>
+          <p:cNvGraphicFramePr>
+            <a:graphicFrameLocks noGrp="1"/>
+          </p:cNvGraphicFramePr>
+          <p:nvPr>
+            <p:extLst>
+              <p:ext uri="{D42A27DB-BD31-4B8C-83A1-F6EECF244321}">
+                <p14:modId xmlns:p14="http://schemas.microsoft.com/office/powerpoint/2010/main" val="3129597800"/>
+              </p:ext>
+            </p:extLst>
+          </p:nvPr>
+        </p:nvGraphicFramePr>
+        <p:xfrm>
+          <a:off x="381000" y="3556000"/>
+          <a:ext cx="5334000" cy="2032000"/>
+        </p:xfrm>
+        <a:graphic>
+          <a:graphicData uri="http://schemas.openxmlformats.org/drawingml/2006/table">
+            <a:tbl>
+              <a:tblPr firstRow="1" bandRow="1">
+                <a:tableStyleId>{5C22544A-7EE6-4342-B048-85BDC9FD1C3A}</a:tableStyleId>
+              </a:tblPr>
+              <a:tblGrid>
+                <a:gridCol w="2667000">
+                  <a:extLst>
+                    <a:ext uri="{9D8B030D-6E8A-4147-A177-3AD203B41FA5}">
+                      <a16:colId xmlns:a16="http://schemas.microsoft.com/office/drawing/2014/main" val="2895984521"/>
+                    </a:ext>
+                  </a:extLst>
+                </a:gridCol>
+                <a:gridCol w="2667000">
+                  <a:extLst>
+                    <a:ext uri="{9D8B030D-6E8A-4147-A177-3AD203B41FA5}">
+                      <a16:colId xmlns:a16="http://schemas.microsoft.com/office/drawing/2014/main" val="457414021"/>
+                    </a:ext>
+                  </a:extLst>
+                </a:gridCol>
+              </a:tblGrid>
+              <a:tr h="1016000">
+                <a:tc>
+                  <a:txBody>
+                    <a:bodyPr/>
+                    <a:lstStyle/>
+                    <a:p>
+                      <a:pPr algn="l"/>
+                      <a:r>
+                        <a:rPr lang="de-DE"/>
+                        <a:t>Short</a:t>
+                      </a:r>
+                    </a:p>
+                    <a:p>
+                      <a:pPr algn="l"/>
+                      <a:r>
+                        <a:rPr lang="de-DE"/>
+                        <a:t>longer second line</a:t>
+                      </a:r>
+                    </a:p>
+                  </a:txBody>
+                  <a:tcPr anchorCtr="1"/>
+                </a:tc>
+                <a:tc>
+                  <a:txBody>
+                    <a:bodyPr/>
+                    <a:lstStyle/>
+                    <a:p>
+                      <a:pPr algn="r"/>
+                      <a:r>
+                        <a:rPr lang="de-DE"/>
+                        <a:t>Short</a:t>
+                      </a:r>
+                    </a:p>
+                    <a:p>
+                      <a:pPr algn="r"/>
+                      <a:r>
+                        <a:rPr lang="de-DE"/>
+                        <a:t>longer second line</a:t>
+                      </a:r>
+                    </a:p>
+                  </a:txBody>
+                  <a:tcPr anchorCtr="1"/>
+                </a:tc>
+                <a:extLst>
+                  <a:ext uri="{0D108BD9-81ED-4DB2-BD59-A6C34878D82A}">
+                    <a16:rowId xmlns:a16="http://schemas.microsoft.com/office/drawing/2014/main" val="273141996"/>
+                  </a:ext>
+                </a:extLst>
+              </a:tr>
+              <a:tr h="1016000">
+                <a:tc>
+                  <a:txBody>
+                    <a:bodyPr/>
+                    <a:lstStyle/>
+                    <a:p>
+                      <a:pPr algn="l"/>
+                      <a:r>
+                        <a:rPr lang="de-DE"/>
+                        <a:t>Short</a:t>
+                      </a:r>
+                    </a:p>
+                    <a:p>
+                      <a:pPr algn="l"/>
+                      <a:r>
+                        <a:rPr lang="de-DE"/>
+                        <a:t>longer second line</a:t>
+                      </a:r>
+                    </a:p>
+                  </a:txBody>
+                  <a:tcPr/>
+                </a:tc>
+                <a:tc>
+                  <a:txBody>
+                    <a:bodyPr/>
+                    <a:lstStyle/>
+                    <a:p>
+                      <a:pPr algn="r"/>
+                      <a:r>
+                        <a:rPr lang="de-DE"/>
+                        <a:t>Short</a:t>
+                      </a:r>
+                    </a:p>
+                    <a:p>
+                      <a:pPr algn="r"/>
+                      <a:r>
+                        <a:rPr lang="de-DE"/>
+                        <a:t>longer second line</a:t>
+                      </a:r>
+                    </a:p>
+                  </a:txBody>
+                  <a:tcPr/>
+                </a:tc>
+                <a:extLst>
+                  <a:ext uri="{0D108BD9-81ED-4DB2-BD59-A6C34878D82A}">
+                    <a16:rowId xmlns:a16="http://schemas.microsoft.com/office/drawing/2014/main" val="1589684404"/>
+                  </a:ext>
+                </a:extLst>
+              </a:tr>
+            </a:tbl>
+          </a:graphicData>
+        </a:graphic>
+      </p:graphicFrame>
+    </p:spTree>
+    <p:extLst>
+      <p:ext uri="{BB962C8B-B14F-4D97-AF65-F5344CB8AC3E}">
+        <p14:creationId xmlns:p14="http://schemas.microsoft.com/office/powerpoint/2010/main" val="2225513821"/>
       </p:ext>
     </p:extLst>
   </p:cSld>

</xml_diff>